<commit_message>
feat: sales deck copy polish for craft-educator audience
All 13 slide headlines rewritten in the artistic register of studio
founders (art/music/dance) — evocative titles, concrete bullets; the
four pain cards reframed as time/trust stolen from the craft; CTA ends
on '管理退到幕后，作品站上台前'. Every verified number and price
unchanged; deck re-validated and per-slide render-QA'd; talk track
aligned.

Co-Authored-By: Claude Fable 5 <noreply@anthropic.com>
</commit_message>
<xml_diff>
--- a/docs/sales/PWE_StudioSaaS_销售介绍.pptx
+++ b/docs/sales/PWE_StudioSaaS_销售介绍.pptx
@@ -514,7 +514,7 @@
           <a:p>
             <a:r>
               <a:rPr lang="en-US" dirty="0"/>
-              <a:t>开场:一句话定位——小型创意教育机构的一体化操作系统。强调四个界面覆盖获客到运营全流程。</a:t>
+              <a:t>开场共情:你们开工作室是为了创作与教学,不是为了当会计。这套系统的唯一目的,是把行政偷走的时间还给作品和学生。</a:t>
             </a:r>
             <a:endParaRPr lang="en-US" dirty="0"/>
           </a:p>
@@ -866,7 +866,7 @@
           <a:p>
             <a:r>
               <a:rPr lang="en-US" dirty="0"/>
-              <a:t>收尾:演示承诺具体(30 分钟、现场生成门户)。留下试点名额稀缺感,但不过度承诺。</a:t>
+              <a:t>收尾回到创作:管理退到幕后,作品站上台前。演示承诺具体(30 分钟、现场生成门户),留下试点名额稀缺感,不过度承诺。</a:t>
             </a:r>
             <a:endParaRPr lang="en-US" dirty="0"/>
           </a:p>
@@ -954,7 +954,7 @@
           <a:p>
             <a:r>
               <a:rPr lang="en-US" dirty="0"/>
-              <a:t>共情页:先让对方点头。四个痛点分别对应后面四个产品能力页(报名→审核漏斗,课时→账本,收退费→权限,门面→门户+品牌)。</a:t>
+              <a:t>共情页:先让对方点头——每张卡都是被偷走的时间或信任。四个痛点对应后面四个能力页(询问→家庭端,对账→账本,纸条→权限留痕,作品墙→门户+品牌)。</a:t>
             </a:r>
             <a:endParaRPr lang="en-US" dirty="0"/>
           </a:p>
@@ -2088,7 +2088,7 @@
                 <a:ea typeface="Arial" pitchFamily="34" charset="-122"/>
                 <a:cs typeface="Arial" pitchFamily="34" charset="-120"/>
               </a:rPr>
-              <a:t>创意工作室的一体化操作系统</a:t>
+              <a:t>把时间还给创作</a:t>
             </a:r>
             <a:endParaRPr lang="en-US" sz="4000" dirty="0"/>
           </a:p>
@@ -2127,7 +2127,7 @@
                 <a:ea typeface="Arial" pitchFamily="34" charset="-122"/>
                 <a:cs typeface="Arial" pitchFamily="34" charset="-120"/>
               </a:rPr>
-              <a:t>官网获客 · 在线报名 · 课时运营 · 品牌管理 —— 一套系统全部搞定</a:t>
+              <a:t>官网获客 · 在线报名 · 课时账本 · 品牌门面 —— 琐事交给系统,你回到教室与作品</a:t>
             </a:r>
             <a:endParaRPr lang="en-US" sz="1700" dirty="0"/>
           </a:p>
@@ -2166,7 +2166,7 @@
                 <a:ea typeface="Arial" pitchFamily="34" charset="-122"/>
                 <a:cs typeface="Arial" pitchFamily="34" charset="-120"/>
               </a:rPr>
-              <a:t>面向美术 / 音乐 / 舞蹈工作室与培训机构的多租户 SaaS</a:t>
+              <a:t>创意工作室的一体化操作系统 · 面向美术 / 音乐 / 舞蹈工作室与培训机构</a:t>
             </a:r>
             <a:endParaRPr lang="en-US" sz="1300" dirty="0"/>
           </a:p>
@@ -2599,7 +2599,7 @@
                 <a:ea typeface="Arial" pitchFamily="34" charset="-122"/>
                 <a:cs typeface="Arial" pitchFamily="34" charset="-120"/>
               </a:rPr>
-              <a:t>孩子的数据,值得机构级的保护</a:t>
+              <a:t>孩子的作品与隐私,像原作一样保管</a:t>
             </a:r>
             <a:endParaRPr lang="en-US" sz="2700" dirty="0"/>
           </a:p>
@@ -3432,7 +3432,7 @@
                 <a:ea typeface="Arial" pitchFamily="34" charset="-122"/>
                 <a:cs typeface="Arial" pitchFamily="34" charset="-120"/>
               </a:rPr>
-              <a:t>按机构规模选择,随时可以升级</a:t>
+              <a:t>透明定价,随工作室一起成长</a:t>
             </a:r>
             <a:endParaRPr lang="en-US" sz="2700" dirty="0"/>
           </a:p>
@@ -6208,7 +6208,7 @@
                 <a:ea typeface="Arial" pitchFamily="34" charset="-122"/>
                 <a:cs typeface="Arial" pitchFamily="34" charset="-120"/>
               </a:rPr>
-              <a:t>从签约到开门营业,四步交付</a:t>
+              <a:t>从签约到开幕,只需四步</a:t>
             </a:r>
             <a:endParaRPr lang="en-US" sz="2700" dirty="0"/>
           </a:p>
@@ -7406,7 +7406,7 @@
                 <a:ea typeface="Arial" pitchFamily="34" charset="-122"/>
                 <a:cs typeface="Arial" pitchFamily="34" charset="-120"/>
               </a:rPr>
-              <a:t>把工作室搬进一个系统。</a:t>
+              <a:t>管理退到幕后,作品站上台前。</a:t>
             </a:r>
             <a:endParaRPr lang="en-US" sz="3800" dirty="0"/>
           </a:p>
@@ -7445,7 +7445,7 @@
                 <a:ea typeface="Arial" pitchFamily="34" charset="-122"/>
                 <a:cs typeface="Arial" pitchFamily="34" charset="-120"/>
               </a:rPr>
-              <a:t>预约一次 30 分钟演示:用你机构的名字、品牌和课程,现场生成一个可预览的门户。</a:t>
+              <a:t>预约一次 30 分钟演示:用你工作室的名字、作品和课程,现场生成一个可预览的门户。</a:t>
             </a:r>
             <a:endParaRPr lang="en-US" sz="1500" dirty="0"/>
           </a:p>
@@ -7703,7 +7703,7 @@
                 <a:ea typeface="Arial" pitchFamily="34" charset="-122"/>
                 <a:cs typeface="Arial" pitchFamily="34" charset="-120"/>
               </a:rPr>
-              <a:t>PWE Studio SaaS · 多租户创意工作室操作系统</a:t>
+              <a:t>PWE Studio SaaS · 把时间还给创作</a:t>
             </a:r>
             <a:endParaRPr lang="en-US" sz="1050" dirty="0"/>
           </a:p>
@@ -7833,7 +7833,7 @@
                 <a:ea typeface="Arial" pitchFamily="34" charset="-122"/>
                 <a:cs typeface="Arial" pitchFamily="34" charset="-120"/>
               </a:rPr>
-              <a:t>小机构的运营,散落在五个地方</a:t>
+              <a:t>你的才华,不该耗在台账和聊天记录里</a:t>
             </a:r>
             <a:endParaRPr lang="en-US" sz="2700" dirty="0"/>
           </a:p>
@@ -7914,7 +7914,7 @@
                 <a:ea typeface="Arial" pitchFamily="34" charset="-122"/>
                 <a:cs typeface="Arial" pitchFamily="34" charset="-120"/>
               </a:rPr>
-              <a:t>报名在微信群、课时在 Excel、收据在抽屉里。</a:t>
+              <a:t>开工作室,是因为热爱创作与教学。</a:t>
             </a:r>
             <a:endParaRPr lang="en-US" sz="1600" dirty="0"/>
           </a:p>
@@ -7934,7 +7934,7 @@
                 <a:ea typeface="Arial" pitchFamily="34" charset="-122"/>
                 <a:cs typeface="Arial" pitchFamily="34" charset="-120"/>
               </a:rPr>
-              <a:t>机构越用心教学,行政越混乱:信息只在某个人的手机里,家长每一次询问都要人工翻记录,数据永远对不齐。</a:t>
+              <a:t>没有人是为了对账、催费、翻聊天记录才创业的。可行政琐事每天都在偷时间——偷走的,本该属于作品和学生。</a:t>
             </a:r>
             <a:endParaRPr lang="en-US" sz="1600" dirty="0"/>
           </a:p>
@@ -7971,7 +7971,7 @@
                 <a:ea typeface="Arial" pitchFamily="34" charset="-122"/>
                 <a:cs typeface="Arial" pitchFamily="34" charset="-120"/>
               </a:rPr>
-              <a:t>换系统的目的不是数字化,是把人从行政琐事里解放出来,回到教学本身。</a:t>
+              <a:t>把琐事交出去,把时间拿回来。</a:t>
             </a:r>
             <a:endParaRPr lang="en-US" sz="1600" dirty="0"/>
           </a:p>
@@ -8076,7 +8076,7 @@
                 <a:ea typeface="Arial" pitchFamily="34" charset="-122"/>
                 <a:cs typeface="Arial" pitchFamily="34" charset="-120"/>
               </a:rPr>
-              <a:t>报名靠微信接龙</a:t>
+              <a:t>被打断的排练</a:t>
             </a:r>
             <a:endParaRPr lang="en-US" sz="1450" dirty="0"/>
           </a:p>
@@ -8115,7 +8115,7 @@
                 <a:ea typeface="Arial" pitchFamily="34" charset="-122"/>
                 <a:cs typeface="Arial" pitchFamily="34" charset="-120"/>
               </a:rPr>
-              <a:t>群消息刷屏,报名字段不全,</a:t>
+              <a:t>『还剩几节课?』一句询问,</a:t>
             </a:r>
             <a:endParaRPr lang="en-US" sz="1100" dirty="0"/>
           </a:p>
@@ -8132,7 +8132,7 @@
                 <a:ea typeface="Arial" pitchFamily="34" charset="-122"/>
                 <a:cs typeface="Arial" pitchFamily="34" charset="-120"/>
               </a:rPr>
-              <a:t>汇总全靠手工复制粘贴</a:t>
+              <a:t>要翻三个月的群记录才答得上</a:t>
             </a:r>
             <a:endParaRPr lang="en-US" sz="1100" dirty="0"/>
           </a:p>
@@ -8237,7 +8237,7 @@
                 <a:ea typeface="Arial" pitchFamily="34" charset="-122"/>
                 <a:cs typeface="Arial" pitchFamily="34" charset="-120"/>
               </a:rPr>
-              <a:t>课时记在 Excel</a:t>
+              <a:t>深夜的对账表</a:t>
             </a:r>
             <a:endParaRPr lang="en-US" sz="1450" dirty="0"/>
           </a:p>
@@ -8276,7 +8276,7 @@
                 <a:ea typeface="Arial" pitchFamily="34" charset="-122"/>
                 <a:cs typeface="Arial" pitchFamily="34" charset="-120"/>
               </a:rPr>
-              <a:t>谁上过课、还剩几次,</a:t>
+              <a:t>白天上课,晚上核 Excel,</a:t>
             </a:r>
             <a:endParaRPr lang="en-US" sz="1100" dirty="0"/>
           </a:p>
@@ -8293,7 +8293,7 @@
                 <a:ea typeface="Arial" pitchFamily="34" charset="-122"/>
                 <a:cs typeface="Arial" pitchFamily="34" charset="-120"/>
               </a:rPr>
-              <a:t>全凭一张随时可能改乱的表</a:t>
+              <a:t>吃掉的是备课和新作品的时间</a:t>
             </a:r>
             <a:endParaRPr lang="en-US" sz="1100" dirty="0"/>
           </a:p>
@@ -8398,7 +8398,7 @@
                 <a:ea typeface="Arial" pitchFamily="34" charset="-122"/>
                 <a:cs typeface="Arial" pitchFamily="34" charset="-120"/>
               </a:rPr>
-              <a:t>收退费缺少留痕</a:t>
+              <a:t>经不起丢的纸条</a:t>
             </a:r>
             <a:endParaRPr lang="en-US" sz="1450" dirty="0"/>
           </a:p>
@@ -8437,7 +8437,7 @@
                 <a:ea typeface="Arial" pitchFamily="34" charset="-122"/>
                 <a:cs typeface="Arial" pitchFamily="34" charset="-120"/>
               </a:rPr>
-              <a:t>口头承诺多、对账困难,</a:t>
+              <a:t>收据在抽屉、承诺在口头,</a:t>
             </a:r>
             <a:endParaRPr lang="en-US" sz="1100" dirty="0"/>
           </a:p>
@@ -8454,7 +8454,7 @@
                 <a:ea typeface="Arial" pitchFamily="34" charset="-122"/>
                 <a:cs typeface="Arial" pitchFamily="34" charset="-120"/>
               </a:rPr>
-              <a:t>退费纠纷说不清楚</a:t>
+              <a:t>家长的信任不该系在一张纸上</a:t>
             </a:r>
             <a:endParaRPr lang="en-US" sz="1100" dirty="0"/>
           </a:p>
@@ -8559,7 +8559,7 @@
                 <a:ea typeface="Arial" pitchFamily="34" charset="-122"/>
                 <a:cs typeface="Arial" pitchFamily="34" charset="-120"/>
               </a:rPr>
-              <a:t>线上门面缺位</a:t>
+              <a:t>看不见的作品墙</a:t>
             </a:r>
             <a:endParaRPr lang="en-US" sz="1450" dirty="0"/>
           </a:p>
@@ -8598,7 +8598,7 @@
                 <a:ea typeface="Arial" pitchFamily="34" charset="-122"/>
                 <a:cs typeface="Arial" pitchFamily="34" charset="-120"/>
               </a:rPr>
-              <a:t>没有像样的官网与作品展示,</a:t>
+              <a:t>作品攒了一屋子,线上无处可看,</a:t>
             </a:r>
             <a:endParaRPr lang="en-US" sz="1100" dirty="0"/>
           </a:p>
@@ -8615,7 +8615,7 @@
                 <a:ea typeface="Arial" pitchFamily="34" charset="-122"/>
                 <a:cs typeface="Arial" pitchFamily="34" charset="-120"/>
               </a:rPr>
-              <a:t>获客只能靠转介绍</a:t>
+              <a:t>新学员只能靠转介绍</a:t>
             </a:r>
             <a:endParaRPr lang="en-US" sz="1100" dirty="0"/>
           </a:p>
@@ -8745,7 +8745,7 @@
                 <a:ea typeface="Arial" pitchFamily="34" charset="-122"/>
                 <a:cs typeface="Arial" pitchFamily="34" charset="-120"/>
               </a:rPr>
-              <a:t>每家机构开通即得四个界面,平台侧一个控制台</a:t>
+              <a:t>台前是你的品牌,幕后是一个系统</a:t>
             </a:r>
             <a:endParaRPr lang="en-US" sz="2700" dirty="0"/>
           </a:p>
@@ -9994,7 +9994,7 @@
                 <a:ea typeface="Arial" pitchFamily="34" charset="-122"/>
                 <a:cs typeface="Arial" pitchFamily="34" charset="-120"/>
               </a:rPr>
-              <a:t>一个拿得出手的官网,报名不再流失</a:t>
+              <a:t>把作品挂上网,把报名开进门</a:t>
             </a:r>
             <a:endParaRPr lang="en-US" sz="2700" dirty="0"/>
           </a:p>
@@ -11082,7 +11082,7 @@
                 <a:ea typeface="Arial" pitchFamily="34" charset="-122"/>
                 <a:cs typeface="Arial" pitchFamily="34" charset="-120"/>
               </a:rPr>
-              <a:t>从访客到学员,每一步都有秩序</a:t>
+              <a:t>从询价到开课,不乱一个节拍</a:t>
             </a:r>
             <a:endParaRPr lang="en-US" sz="2700" dirty="0"/>
           </a:p>
@@ -12257,7 +12257,7 @@
                 <a:ea typeface="Arial" pitchFamily="34" charset="-122"/>
                 <a:cs typeface="Arial" pitchFamily="34" charset="-120"/>
               </a:rPr>
-              <a:t>签到即扣课时,每一节课都有账可查</a:t>
+              <a:t>每一节课的去向,像五线谱一样清晰</a:t>
             </a:r>
             <a:endParaRPr lang="en-US" sz="2700" dirty="0"/>
           </a:p>
@@ -13701,7 +13701,7 @@
                 <a:ea typeface="Arial" pitchFamily="34" charset="-122"/>
                 <a:cs typeface="Arial" pitchFamily="34" charset="-120"/>
               </a:rPr>
-              <a:t>谁能退费,系统说了算,不靠口头约定</a:t>
+              <a:t>钱上的规矩写进系统,不写在人情里</a:t>
             </a:r>
             <a:endParaRPr lang="en-US" sz="2700" dirty="0"/>
           </a:p>
@@ -16790,7 +16790,7 @@
                 <a:ea typeface="Arial" pitchFamily="34" charset="-122"/>
                 <a:cs typeface="Arial" pitchFamily="34" charset="-120"/>
               </a:rPr>
-              <a:t>你的机构,长你自己的样子</a:t>
+              <a:t>你的工作室,值得和作品一样讲究的门面</a:t>
             </a:r>
             <a:endParaRPr lang="en-US" sz="2700" dirty="0"/>
           </a:p>
@@ -18225,7 +18225,7 @@
                 <a:ea typeface="Arial" pitchFamily="34" charset="-122"/>
                 <a:cs typeface="Arial" pitchFamily="34" charset="-120"/>
               </a:rPr>
-              <a:t>家长不用装 App,也不用再问前台</a:t>
+              <a:t>家长看到的不是数字,是孩子的成长轨迹</a:t>
             </a:r>
             <a:endParaRPr lang="en-US" sz="2700" dirty="0"/>
           </a:p>
@@ -19141,7 +19141,7 @@
                 <a:ea typeface="Arial" pitchFamily="34" charset="-122"/>
                 <a:cs typeface="Arial" pitchFamily="34" charset="-120"/>
               </a:rPr>
-              <a:t>省下来的,是前台每天几十次「还剩几节课」的重复回答,和家长等待答复的耐心。</a:t>
+              <a:t>省下来的,是前台每天几十次的重复报数;留下来的,是家长随时翻得到的成长记录。</a:t>
             </a:r>
             <a:endParaRPr lang="en-US" sz="1200" dirty="0"/>
           </a:p>

</xml_diff>

<commit_message>
feat: Crafted P brand mark (round 2) + Paradise Production credit
Client-approved candidate D replaces the monoline mark (82 vs 64 on the
12-criteria acceptance rubric): solid P with the amber spark as the
bowl's counter — bowl 60.5% cap height, superelliptical shoulders,
tapered stem, ink trap. Wordmark P reworked to match; lockup optically
rebalanced; all root assets regenerated from the single-source
generator; Super Admin header mark updated; manifests unchanged.

Brand architecture (client decision): product brand stays PWE Studio
SaaS with the Paradise WE story; producer credit 'A PARADISE PRODUCTION
· 天域文创出品' added as a quiet endorser (canonical single form, spec
in Brand_Identity §10) — sales deck cover/closing, Super Admin login
footer, README footer only; forbidden on tenant surfaces.

Round-2 exploration archived under docs/design/brand/round2/.

Co-Authored-By: Claude Fable 5 <noreply@anthropic.com>
</commit_message>
<xml_diff>
--- a/docs/sales/PWE_StudioSaaS_销售介绍.pptx
+++ b/docs/sales/PWE_StudioSaaS_销售介绍.pptx
@@ -2475,6 +2475,45 @@
           </a:p>
         </p:txBody>
       </p:sp>
+      <p:sp>
+        <p:nvSpPr>
+          <p:cNvPr id="19" name="Text 16"/>
+          <p:cNvSpPr/>
+          <p:nvPr/>
+        </p:nvSpPr>
+        <p:spPr>
+          <a:xfrm>
+            <a:off x="6976872" y="6281928"/>
+            <a:ext cx="4389120" cy="237744"/>
+          </a:xfrm>
+          <a:prstGeom prst="rect">
+            <a:avLst/>
+          </a:prstGeom>
+          <a:noFill/>
+          <a:ln/>
+        </p:spPr>
+        <p:txBody>
+          <a:bodyPr wrap="square" lIns="0" tIns="0" rIns="0" bIns="0" rtlCol="0" anchor="ctr"/>
+          <a:lstStyle/>
+          <a:p>
+            <a:pPr algn="r" indent="0" marL="0">
+              <a:buNone/>
+            </a:pPr>
+            <a:r>
+              <a:rPr lang="en-US" sz="800" b="1" spc="75" kern="0" dirty="0">
+                <a:solidFill>
+                  <a:srgbClr val="94A3B8"/>
+                </a:solidFill>
+                <a:latin typeface="Arial" pitchFamily="34" charset="0"/>
+                <a:ea typeface="Arial" pitchFamily="34" charset="-122"/>
+                <a:cs typeface="Arial" pitchFamily="34" charset="-120"/>
+              </a:rPr>
+              <a:t>A PARADISE PRODUCTION · 天域文创出品</a:t>
+            </a:r>
+            <a:endParaRPr lang="en-US" sz="800" dirty="0"/>
+          </a:p>
+        </p:txBody>
+      </p:sp>
     </p:spTree>
   </p:cSld>
   <p:clrMapOvr>
@@ -7706,6 +7745,45 @@
               <a:t>PWE Studio SaaS · 把时间还给创作</a:t>
             </a:r>
             <a:endParaRPr lang="en-US" sz="1050" dirty="0"/>
+          </a:p>
+        </p:txBody>
+      </p:sp>
+      <p:sp>
+        <p:nvSpPr>
+          <p:cNvPr id="15" name="Text 12"/>
+          <p:cNvSpPr/>
+          <p:nvPr/>
+        </p:nvSpPr>
+        <p:spPr>
+          <a:xfrm>
+            <a:off x="6976872" y="6281928"/>
+            <a:ext cx="4389120" cy="237744"/>
+          </a:xfrm>
+          <a:prstGeom prst="rect">
+            <a:avLst/>
+          </a:prstGeom>
+          <a:noFill/>
+          <a:ln/>
+        </p:spPr>
+        <p:txBody>
+          <a:bodyPr wrap="square" lIns="0" tIns="0" rIns="0" bIns="0" rtlCol="0" anchor="ctr"/>
+          <a:lstStyle/>
+          <a:p>
+            <a:pPr algn="r" indent="0" marL="0">
+              <a:buNone/>
+            </a:pPr>
+            <a:r>
+              <a:rPr lang="en-US" sz="800" b="1" spc="75" kern="0" dirty="0">
+                <a:solidFill>
+                  <a:srgbClr val="94A3B8"/>
+                </a:solidFill>
+                <a:latin typeface="Arial" pitchFamily="34" charset="0"/>
+                <a:ea typeface="Arial" pitchFamily="34" charset="-122"/>
+                <a:cs typeface="Arial" pitchFamily="34" charset="-120"/>
+              </a:rPr>
+              <a:t>A PARADISE PRODUCTION · 天域文创出品</a:t>
+            </a:r>
+            <a:endParaRPr lang="en-US" sz="800" dirty="0"/>
           </a:p>
         </p:txBody>
       </p:sp>

</xml_diff>

<commit_message>
feat: release v7.8.0 brand system
</commit_message>
<xml_diff>
--- a/docs/sales/PWE_StudioSaaS_销售介绍.pptx
+++ b/docs/sales/PWE_StudioSaaS_销售介绍.pptx
@@ -2,25 +2,25 @@
 <file path=ppt/presentation.xml><?xml version="1.0" encoding="utf-8"?>
 <p:presentation xmlns:p="http://schemas.openxmlformats.org/presentationml/2006/main">
   <p:sldMasterIdLst>
-    <p:sldMasterId xmlns:r="http://schemas.openxmlformats.org/officeDocument/2006/relationships" id="2147483648" r:id="Re5914cce25164f26"/>
+    <p:sldMasterId xmlns:r="http://schemas.openxmlformats.org/officeDocument/2006/relationships" id="2147483648" r:id="Rf082074271c1497d"/>
   </p:sldMasterIdLst>
   <p:notesMasterIdLst>
-    <p:notesMasterId xmlns:r="http://schemas.openxmlformats.org/officeDocument/2006/relationships" r:id="R328706caf0f342c0"/>
+    <p:notesMasterId xmlns:r="http://schemas.openxmlformats.org/officeDocument/2006/relationships" r:id="Ra86ad48324cc41f7"/>
   </p:notesMasterIdLst>
   <p:sldIdLst>
-    <p:sldId xmlns:r="http://schemas.openxmlformats.org/officeDocument/2006/relationships" id="256" r:id="R0aedbe9d305346b1"/>
-    <p:sldId xmlns:r="http://schemas.openxmlformats.org/officeDocument/2006/relationships" id="257" r:id="Rbdc924f2bf99419c"/>
-    <p:sldId xmlns:r="http://schemas.openxmlformats.org/officeDocument/2006/relationships" id="258" r:id="R170b6476625a4e04"/>
-    <p:sldId xmlns:r="http://schemas.openxmlformats.org/officeDocument/2006/relationships" id="259" r:id="R2d6834fa578e4614"/>
-    <p:sldId xmlns:r="http://schemas.openxmlformats.org/officeDocument/2006/relationships" id="260" r:id="R50cb4c3685f84f3d"/>
-    <p:sldId xmlns:r="http://schemas.openxmlformats.org/officeDocument/2006/relationships" id="261" r:id="Raa993b0f1f524d5b"/>
-    <p:sldId xmlns:r="http://schemas.openxmlformats.org/officeDocument/2006/relationships" id="262" r:id="R40f4174fa719484a"/>
-    <p:sldId xmlns:r="http://schemas.openxmlformats.org/officeDocument/2006/relationships" id="263" r:id="R7958f92642134dfe"/>
-    <p:sldId xmlns:r="http://schemas.openxmlformats.org/officeDocument/2006/relationships" id="264" r:id="R58ff3d13fcc145b0"/>
-    <p:sldId xmlns:r="http://schemas.openxmlformats.org/officeDocument/2006/relationships" id="265" r:id="Rd18ff00b232e4bcf"/>
-    <p:sldId xmlns:r="http://schemas.openxmlformats.org/officeDocument/2006/relationships" id="266" r:id="Re5594ef3439e4a50"/>
-    <p:sldId xmlns:r="http://schemas.openxmlformats.org/officeDocument/2006/relationships" id="267" r:id="Rb16bebfddf0b44a7"/>
-    <p:sldId xmlns:r="http://schemas.openxmlformats.org/officeDocument/2006/relationships" id="268" r:id="Racc80040f21940e4"/>
+    <p:sldId xmlns:r="http://schemas.openxmlformats.org/officeDocument/2006/relationships" id="256" r:id="R2a8a16df53ab4fd8"/>
+    <p:sldId xmlns:r="http://schemas.openxmlformats.org/officeDocument/2006/relationships" id="257" r:id="R930f3c055163407d"/>
+    <p:sldId xmlns:r="http://schemas.openxmlformats.org/officeDocument/2006/relationships" id="258" r:id="R26b563b7dd9c491d"/>
+    <p:sldId xmlns:r="http://schemas.openxmlformats.org/officeDocument/2006/relationships" id="259" r:id="R5230d2854606493c"/>
+    <p:sldId xmlns:r="http://schemas.openxmlformats.org/officeDocument/2006/relationships" id="260" r:id="R538f23b5991b4821"/>
+    <p:sldId xmlns:r="http://schemas.openxmlformats.org/officeDocument/2006/relationships" id="261" r:id="R3ebe3b37ee194536"/>
+    <p:sldId xmlns:r="http://schemas.openxmlformats.org/officeDocument/2006/relationships" id="262" r:id="R865e2ca08e6047ed"/>
+    <p:sldId xmlns:r="http://schemas.openxmlformats.org/officeDocument/2006/relationships" id="263" r:id="R62438c0d9a364294"/>
+    <p:sldId xmlns:r="http://schemas.openxmlformats.org/officeDocument/2006/relationships" id="264" r:id="R3c020470998d48c7"/>
+    <p:sldId xmlns:r="http://schemas.openxmlformats.org/officeDocument/2006/relationships" id="265" r:id="R0d7a9f551c3d46a7"/>
+    <p:sldId xmlns:r="http://schemas.openxmlformats.org/officeDocument/2006/relationships" id="266" r:id="R332447855d5047a9"/>
+    <p:sldId xmlns:r="http://schemas.openxmlformats.org/officeDocument/2006/relationships" id="267" r:id="R635e2ef593524809"/>
+    <p:sldId xmlns:r="http://schemas.openxmlformats.org/officeDocument/2006/relationships" id="268" r:id="R9d90bf5f573249fb"/>
   </p:sldIdLst>
   <p:sldSz cx="12192000" cy="6858000"/>
   <p:notesSz cx="6858000" cy="9144000"/>
@@ -172,15 +172,15 @@
 <file path=ppt/notesMasters/theme/theme3.xml><?xml version="1.0" encoding="utf-8"?>
 <a:theme xmlns:a="http://schemas.openxmlformats.org/drawingml/2006/main" name="Office Theme">
   <a:themeElements>
-    <a:clrScheme name="Office">
+    <a:clrScheme name="PWE Studio Family">
       <a:dk1>
-        <a:sysClr val="windowText" lastClr="000000"/>
+        <a:srgbClr val="000000"/>
       </a:dk1>
       <a:lt1>
-        <a:sysClr val="window" lastClr="FFFFFF"/>
+        <a:srgbClr val="FFFFFF"/>
       </a:lt1>
       <a:dk2>
-        <a:srgbClr val="44546A"/>
+        <a:srgbClr val="16233D"/>
       </a:dk2>
       <a:lt2>
         <a:srgbClr val="E7E6E6"/>
@@ -195,7 +195,7 @@
         <a:srgbClr val="A5A5A5"/>
       </a:accent3>
       <a:accent4>
-        <a:srgbClr val="FFC000"/>
+        <a:srgbClr val="F5B335"/>
       </a:accent4>
       <a:accent5>
         <a:srgbClr val="5B9BD5"/>
@@ -204,7 +204,7 @@
         <a:srgbClr val="70AD47"/>
       </a:accent6>
       <a:hlink>
-        <a:srgbClr val="0563C1"/>
+        <a:srgbClr val="2563EB"/>
       </a:hlink>
       <a:folHlink>
         <a:srgbClr val="954F72"/>
@@ -316,7 +316,7 @@
         <a:font script="Tfng" typeface="Ebrima"/>
       </a:minorFont>
     </a:fontScheme>
-    <a:fmtScheme name="Office">
+    <a:fmtScheme name="PWE Studio Family">
       <a:fillStyleLst>
         <a:solidFill>
           <a:schemeClr val="phClr"/>
@@ -494,7 +494,22 @@
           <a:lstStyle xmlns:a="http://schemas.openxmlformats.org/drawingml/2006/main"/>
           <a:p xmlns:a="http://schemas.openxmlformats.org/drawingml/2006/main">
             <a:r>
-              <a:t>开场共情:你们开工作室是为了创作与教学,不是为了当会计。这套系统的唯一目的,是把行政偷走的时间还给作品和学生。</a:t>
+              <a:t>[Sources]</a:t>
+            </a:r>
+          </a:p>
+          <a:p xmlns:a="http://schemas.openxmlformats.org/drawingml/2006/main">
+            <a:r>
+              <a:t>- 01 BRAND ASSETS/brand-tokens.json</a:t>
+            </a:r>
+          </a:p>
+          <a:p xmlns:a="http://schemas.openxmlformats.org/drawingml/2006/main">
+            <a:r>
+              <a:t>- 01 BRAND ASSETS/logo/lockup-C-on-navy.svg</a:t>
+            </a:r>
+          </a:p>
+          <a:p xmlns:a="http://schemas.openxmlformats.org/drawingml/2006/main">
+            <a:r>
+              <a:t>- docs/design/brand/render_assets.py</a:t>
             </a:r>
           </a:p>
         </p:txBody>
@@ -774,7 +789,22 @@
           <a:lstStyle xmlns:a="http://schemas.openxmlformats.org/drawingml/2006/main"/>
           <a:p xmlns:a="http://schemas.openxmlformats.org/drawingml/2006/main">
             <a:r>
-              <a:t>收尾回到创作:管理退到幕后,作品站上台前。演示承诺具体(30 分钟、现场生成门户),留下试点名额稀缺感,不过度承诺。</a:t>
+              <a:t>[Sources]</a:t>
+            </a:r>
+          </a:p>
+          <a:p xmlns:a="http://schemas.openxmlformats.org/drawingml/2006/main">
+            <a:r>
+              <a:t>- 01 BRAND ASSETS/brand-tokens.json</a:t>
+            </a:r>
+          </a:p>
+          <a:p xmlns:a="http://schemas.openxmlformats.org/drawingml/2006/main">
+            <a:r>
+              <a:t>- 01 BRAND ASSETS/logo/lockup-C-on-navy.svg</a:t>
+            </a:r>
+          </a:p>
+          <a:p xmlns:a="http://schemas.openxmlformats.org/drawingml/2006/main">
+            <a:r>
+              <a:t>- docs/design/brand/render_assets.py</a:t>
             </a:r>
           </a:p>
         </p:txBody>
@@ -1402,7 +1432,7 @@
   </p:cSld>
   <p:clrMap bg1="lt1" tx1="dk1" bg2="lt2" tx2="dk2" accent1="accent1" accent2="accent2" accent3="accent3" accent4="accent4" accent5="accent5" accent6="accent6" hlink="hlink" folHlink="folHlink"/>
   <p:sldLayoutIdLst>
-    <p:sldLayoutId xmlns:r="http://schemas.openxmlformats.org/officeDocument/2006/relationships" id="2147483649" r:id="Re0df779fbc9941df"/>
+    <p:sldLayoutId xmlns:r="http://schemas.openxmlformats.org/officeDocument/2006/relationships" id="2147483649" r:id="R5567a35b44f64cac"/>
   </p:sldLayoutIdLst>
   <p:hf sldNum="0" hdr="0" ftr="0" dt="0"/>
   <p:txStyles>
@@ -1955,7 +1985,7 @@
     <p:bg>
       <p:bgPr>
         <a:solidFill xmlns:a="http://schemas.openxmlformats.org/drawingml/2006/main">
-          <a:srgbClr val="0F172A"/>
+          <a:srgbClr val="0E1729"/>
         </a:solidFill>
       </p:bgPr>
     </p:bg>
@@ -2086,17 +2116,15 @@
       </p:sp>
       <p:pic>
         <p:nvPicPr>
-          <p:cNvPr id="25" name="Image 0"/>
+          <p:cNvPr id="26" name="Image 0"/>
           <p:cNvPicPr>
             <a:picLocks xmlns:a="http://schemas.openxmlformats.org/drawingml/2006/main" noChangeAspect="1"/>
           </p:cNvPicPr>
           <p:nvPr/>
         </p:nvPicPr>
         <p:blipFill>
-          <a:blip xmlns:r="http://schemas.openxmlformats.org/officeDocument/2006/relationships" xmlns:a="http://schemas.openxmlformats.org/drawingml/2006/main" r:embed="Rd89bab3eb658477c"/>
-          <a:stretch xmlns:a="http://schemas.openxmlformats.org/drawingml/2006/main">
-            <a:fillRect l="0" t="0" r="0" b="0"/>
-          </a:stretch>
+          <a:blip xmlns:r="http://schemas.openxmlformats.org/officeDocument/2006/relationships" xmlns:a="http://schemas.openxmlformats.org/drawingml/2006/main" r:embed="R2c9400428f494073"/>
+          <a:stretch xmlns:a="http://schemas.openxmlformats.org/drawingml/2006/main"/>
         </p:blipFill>
         <p:spPr>
           <a:xfrm xmlns:a="http://schemas.openxmlformats.org/drawingml/2006/main">
@@ -2142,7 +2170,7 @@
             <a:r>
               <a:rPr sz="4000" b="1">
                 <a:solidFill>
-                  <a:srgbClr val="F8FAFC"/>
+                  <a:srgbClr val="FFFFFF"/>
                 </a:solidFill>
                 <a:latin typeface="Arial"/>
                 <a:ea typeface="Arial"/>
@@ -2268,11 +2296,11 @@
             </a:avLst>
           </a:prstGeom>
           <a:solidFill xmlns:a="http://schemas.openxmlformats.org/drawingml/2006/main">
-            <a:srgbClr val="0F172A"/>
+            <a:srgbClr val="0E1729"/>
           </a:solidFill>
           <a:ln xmlns:a="http://schemas.openxmlformats.org/drawingml/2006/main" w="12700">
             <a:solidFill>
-              <a:srgbClr val="334155"/>
+              <a:srgbClr val="22355A"/>
             </a:solidFill>
             <a:prstDash val="solid"/>
           </a:ln>
@@ -2348,11 +2376,11 @@
             </a:avLst>
           </a:prstGeom>
           <a:solidFill xmlns:a="http://schemas.openxmlformats.org/drawingml/2006/main">
-            <a:srgbClr val="0F172A"/>
+            <a:srgbClr val="0E1729"/>
           </a:solidFill>
           <a:ln xmlns:a="http://schemas.openxmlformats.org/drawingml/2006/main" w="12700">
             <a:solidFill>
-              <a:srgbClr val="334155"/>
+              <a:srgbClr val="22355A"/>
             </a:solidFill>
             <a:prstDash val="solid"/>
           </a:ln>
@@ -2428,11 +2456,11 @@
             </a:avLst>
           </a:prstGeom>
           <a:solidFill xmlns:a="http://schemas.openxmlformats.org/drawingml/2006/main">
-            <a:srgbClr val="0F172A"/>
+            <a:srgbClr val="0E1729"/>
           </a:solidFill>
           <a:ln xmlns:a="http://schemas.openxmlformats.org/drawingml/2006/main" w="12700">
             <a:solidFill>
-              <a:srgbClr val="334155"/>
+              <a:srgbClr val="22355A"/>
             </a:solidFill>
             <a:prstDash val="solid"/>
           </a:ln>
@@ -2508,11 +2536,11 @@
             </a:avLst>
           </a:prstGeom>
           <a:solidFill xmlns:a="http://schemas.openxmlformats.org/drawingml/2006/main">
-            <a:srgbClr val="0F172A"/>
+            <a:srgbClr val="0E1729"/>
           </a:solidFill>
           <a:ln xmlns:a="http://schemas.openxmlformats.org/drawingml/2006/main" w="12700">
             <a:solidFill>
-              <a:srgbClr val="334155"/>
+              <a:srgbClr val="22355A"/>
             </a:solidFill>
             <a:prstDash val="solid"/>
           </a:ln>
@@ -2558,7 +2586,7 @@
                 <a:ea typeface="Arial"/>
                 <a:cs typeface="Arial"/>
               </a:rPr>
-              <a:t>v7.7.8</a:t>
+              <a:t>v7.8.0</a:t>
             </a:r>
           </a:p>
         </p:txBody>
@@ -2608,51 +2636,28 @@
           </a:p>
         </p:txBody>
       </p:sp>
-      <p:sp>
-        <p:nvSpPr>
-          <p:cNvPr id="19" name="Text 16">
-            <a:extLst xmlns:a="http://schemas.openxmlformats.org/drawingml/2006/main">
-              <a:ext uri="{FF2B5EF4-FFF2-40B4-BE49-F238E27FC236}">
-                <a16:creationId xmlns:a16="http://schemas.microsoft.com/office/drawing/2014/main" id="{8ED12F7E-5644-44EE-818F-3E70946158B6}"/>
-              </a:ext>
-            </a:extLst>
-          </p:cNvPr>
-          <p:cNvSpPr>
-            <a:spLocks xmlns:a="http://schemas.openxmlformats.org/drawingml/2006/main" noGrp="1"/>
-          </p:cNvSpPr>
-          <p:nvPr/>
-        </p:nvSpPr>
-        <p:spPr>
-          <a:xfrm xmlns:a="http://schemas.openxmlformats.org/drawingml/2006/main">
-            <a:off x="6976872" y="6281928"/>
-            <a:ext cx="4389120" cy="237744"/>
-          </a:xfrm>
-          <a:prstGeom xmlns:a="http://schemas.openxmlformats.org/drawingml/2006/main" prst="rect">
-            <a:avLst/>
-          </a:prstGeom>
-          <a:noFill xmlns:a="http://schemas.openxmlformats.org/drawingml/2006/main"/>
-        </p:spPr>
-        <p:txBody>
-          <a:bodyPr xmlns:a="http://schemas.openxmlformats.org/drawingml/2006/main" wrap="square" lIns="0" tIns="0" rIns="0" bIns="0" anchor="ctr"/>
-          <a:lstStyle xmlns:a="http://schemas.openxmlformats.org/drawingml/2006/main"/>
-          <a:p xmlns:a="http://schemas.openxmlformats.org/drawingml/2006/main">
-            <a:pPr marL="0" indent="0" algn="r">
-              <a:buNone/>
-            </a:pPr>
-            <a:r>
-              <a:rPr sz="800" b="1">
-                <a:solidFill>
-                  <a:srgbClr val="94A3B8"/>
-                </a:solidFill>
-                <a:latin typeface="Arial"/>
-                <a:ea typeface="Arial"/>
-                <a:cs typeface="Arial"/>
-              </a:rPr>
-              <a:t>A PARADISE PRODUCTION · 天域文创出品</a:t>
-            </a:r>
-          </a:p>
-        </p:txBody>
-      </p:sp>
+      <p:pic>
+        <p:nvPicPr>
+          <p:cNvPr id="39" name=""/>
+          <p:cNvPicPr>
+            <a:picLocks xmlns:a="http://schemas.openxmlformats.org/drawingml/2006/main" noChangeAspect="1"/>
+          </p:cNvPicPr>
+          <p:nvPr/>
+        </p:nvPicPr>
+        <p:blipFill>
+          <a:blip xmlns:r="http://schemas.openxmlformats.org/officeDocument/2006/relationships" xmlns:a="http://schemas.openxmlformats.org/drawingml/2006/main" r:embed="R406a6df426ad44dd"/>
+          <a:stretch xmlns:a="http://schemas.openxmlformats.org/drawingml/2006/main"/>
+        </p:blipFill>
+        <p:spPr>
+          <a:xfrm xmlns:a="http://schemas.openxmlformats.org/drawingml/2006/main">
+            <a:off x="8763000" y="5963841"/>
+            <a:ext cx="2590800" cy="607219"/>
+          </a:xfrm>
+          <a:prstGeom xmlns:a="http://schemas.openxmlformats.org/drawingml/2006/main" prst="rect">
+            <a:avLst/>
+          </a:prstGeom>
+        </p:spPr>
+      </p:pic>
     </p:spTree>
     <p:extLst>
       <p:ext uri="{BB962C8B-B14F-4D97-AF65-F5344CB8AC3E}">
@@ -2705,7 +2710,7 @@
             <a:avLst/>
           </a:prstGeom>
           <a:solidFill xmlns:a="http://schemas.openxmlformats.org/drawingml/2006/main">
-            <a:srgbClr val="F59E0B"/>
+            <a:srgbClr val="F5B335"/>
           </a:solidFill>
         </p:spPr>
       </p:sp>
@@ -2788,7 +2793,7 @@
             <a:r>
               <a:rPr sz="2700" b="1">
                 <a:solidFill>
-                  <a:srgbClr val="0F172A"/>
+                  <a:srgbClr val="0E1729"/>
                 </a:solidFill>
                 <a:latin typeface="Arial"/>
                 <a:ea typeface="Arial"/>
@@ -2869,7 +2874,7 @@
             </a:avLst>
           </a:prstGeom>
           <a:solidFill xmlns:a="http://schemas.openxmlformats.org/drawingml/2006/main">
-            <a:srgbClr val="F8FAFC"/>
+            <a:srgbClr val="FBFAF7"/>
           </a:solidFill>
           <a:ln xmlns:a="http://schemas.openxmlformats.org/drawingml/2006/main" w="12700">
             <a:solidFill>
@@ -2904,7 +2909,7 @@
             </a:avLst>
           </a:prstGeom>
           <a:solidFill xmlns:a="http://schemas.openxmlformats.org/drawingml/2006/main">
-            <a:srgbClr val="0F172A"/>
+            <a:srgbClr val="0E1729"/>
           </a:solidFill>
         </p:spPr>
       </p:sp>
@@ -2987,7 +2992,7 @@
             <a:r>
               <a:rPr sz="1450" b="1">
                 <a:solidFill>
-                  <a:srgbClr val="0F172A"/>
+                  <a:srgbClr val="0E1729"/>
                 </a:solidFill>
                 <a:latin typeface="Arial"/>
                 <a:ea typeface="Arial"/>
@@ -3068,7 +3073,7 @@
             </a:avLst>
           </a:prstGeom>
           <a:solidFill xmlns:a="http://schemas.openxmlformats.org/drawingml/2006/main">
-            <a:srgbClr val="F8FAFC"/>
+            <a:srgbClr val="FBFAF7"/>
           </a:solidFill>
           <a:ln xmlns:a="http://schemas.openxmlformats.org/drawingml/2006/main" w="12700">
             <a:solidFill>
@@ -3103,7 +3108,7 @@
             </a:avLst>
           </a:prstGeom>
           <a:solidFill xmlns:a="http://schemas.openxmlformats.org/drawingml/2006/main">
-            <a:srgbClr val="F59E0B"/>
+            <a:srgbClr val="F5B335"/>
           </a:solidFill>
         </p:spPr>
       </p:sp>
@@ -3141,7 +3146,7 @@
             <a:r>
               <a:rPr sz="1500" b="1">
                 <a:solidFill>
-                  <a:srgbClr val="0F172A"/>
+                  <a:srgbClr val="0E1729"/>
                 </a:solidFill>
                 <a:latin typeface="Arial"/>
                 <a:ea typeface="Arial"/>
@@ -3186,7 +3191,7 @@
             <a:r>
               <a:rPr sz="1450" b="1">
                 <a:solidFill>
-                  <a:srgbClr val="0F172A"/>
+                  <a:srgbClr val="0E1729"/>
                 </a:solidFill>
                 <a:latin typeface="Arial"/>
                 <a:ea typeface="Arial"/>
@@ -3267,7 +3272,7 @@
             </a:avLst>
           </a:prstGeom>
           <a:solidFill xmlns:a="http://schemas.openxmlformats.org/drawingml/2006/main">
-            <a:srgbClr val="F8FAFC"/>
+            <a:srgbClr val="FBFAF7"/>
           </a:solidFill>
           <a:ln xmlns:a="http://schemas.openxmlformats.org/drawingml/2006/main" w="12700">
             <a:solidFill>
@@ -3302,7 +3307,7 @@
             </a:avLst>
           </a:prstGeom>
           <a:solidFill xmlns:a="http://schemas.openxmlformats.org/drawingml/2006/main">
-            <a:srgbClr val="0F172A"/>
+            <a:srgbClr val="0E1729"/>
           </a:solidFill>
         </p:spPr>
       </p:sp>
@@ -3385,7 +3390,7 @@
             <a:r>
               <a:rPr sz="1450" b="1">
                 <a:solidFill>
-                  <a:srgbClr val="0F172A"/>
+                  <a:srgbClr val="0E1729"/>
                 </a:solidFill>
                 <a:latin typeface="Arial"/>
                 <a:ea typeface="Arial"/>
@@ -3466,7 +3471,7 @@
             </a:avLst>
           </a:prstGeom>
           <a:solidFill xmlns:a="http://schemas.openxmlformats.org/drawingml/2006/main">
-            <a:srgbClr val="F8FAFC"/>
+            <a:srgbClr val="FBFAF7"/>
           </a:solidFill>
           <a:ln xmlns:a="http://schemas.openxmlformats.org/drawingml/2006/main" w="12700">
             <a:solidFill>
@@ -3501,7 +3506,7 @@
             </a:avLst>
           </a:prstGeom>
           <a:solidFill xmlns:a="http://schemas.openxmlformats.org/drawingml/2006/main">
-            <a:srgbClr val="0F172A"/>
+            <a:srgbClr val="0E1729"/>
           </a:solidFill>
         </p:spPr>
       </p:sp>
@@ -3584,7 +3589,7 @@
             <a:r>
               <a:rPr sz="1450" b="1">
                 <a:solidFill>
-                  <a:srgbClr val="0F172A"/>
+                  <a:srgbClr val="0E1729"/>
                 </a:solidFill>
                 <a:latin typeface="Arial"/>
                 <a:ea typeface="Arial"/>
@@ -3692,7 +3697,7 @@
             <a:avLst/>
           </a:prstGeom>
           <a:solidFill xmlns:a="http://schemas.openxmlformats.org/drawingml/2006/main">
-            <a:srgbClr val="F59E0B"/>
+            <a:srgbClr val="F5B335"/>
           </a:solidFill>
         </p:spPr>
       </p:sp>
@@ -3775,7 +3780,7 @@
             <a:r>
               <a:rPr sz="2700" b="1">
                 <a:solidFill>
-                  <a:srgbClr val="0F172A"/>
+                  <a:srgbClr val="0E1729"/>
                 </a:solidFill>
                 <a:latin typeface="Arial"/>
                 <a:ea typeface="Arial"/>
@@ -5874,7 +5879,7 @@
             <a:avLst/>
           </a:prstGeom>
           <a:solidFill xmlns:a="http://schemas.openxmlformats.org/drawingml/2006/main">
-            <a:srgbClr val="F59E0B"/>
+            <a:srgbClr val="F5B335"/>
           </a:solidFill>
         </p:spPr>
       </p:sp>
@@ -5957,7 +5962,7 @@
             <a:r>
               <a:rPr sz="2700" b="1">
                 <a:solidFill>
-                  <a:srgbClr val="0F172A"/>
+                  <a:srgbClr val="0E1729"/>
                 </a:solidFill>
                 <a:latin typeface="Arial"/>
                 <a:ea typeface="Arial"/>
@@ -6067,7 +6072,7 @@
             <a:avLst/>
           </a:prstGeom>
           <a:solidFill xmlns:a="http://schemas.openxmlformats.org/drawingml/2006/main">
-            <a:srgbClr val="0F172A"/>
+            <a:srgbClr val="0E1729"/>
           </a:solidFill>
         </p:spPr>
       </p:sp>
@@ -6141,7 +6146,7 @@
             </a:avLst>
           </a:prstGeom>
           <a:solidFill xmlns:a="http://schemas.openxmlformats.org/drawingml/2006/main">
-            <a:srgbClr val="F8FAFC"/>
+            <a:srgbClr val="FBFAF7"/>
           </a:solidFill>
           <a:ln xmlns:a="http://schemas.openxmlformats.org/drawingml/2006/main" w="12700">
             <a:solidFill>
@@ -6174,7 +6179,7 @@
             <a:avLst/>
           </a:prstGeom>
           <a:solidFill xmlns:a="http://schemas.openxmlformats.org/drawingml/2006/main">
-            <a:srgbClr val="0F172A"/>
+            <a:srgbClr val="0E1729"/>
           </a:solidFill>
         </p:spPr>
       </p:sp>
@@ -6187,7 +6192,7 @@
           <p:nvPr/>
         </p:nvPicPr>
         <p:blipFill>
-          <a:blip xmlns:r="http://schemas.openxmlformats.org/officeDocument/2006/relationships" xmlns:a="http://schemas.openxmlformats.org/drawingml/2006/main" r:embed="R32e6d8efc2754add"/>
+          <a:blip xmlns:r="http://schemas.openxmlformats.org/officeDocument/2006/relationships" xmlns:a="http://schemas.openxmlformats.org/drawingml/2006/main" r:embed="R11d9006c41e54eac"/>
           <a:stretch xmlns:a="http://schemas.openxmlformats.org/drawingml/2006/main">
             <a:fillRect l="0" t="0" r="0" b="0"/>
           </a:stretch>
@@ -6236,7 +6241,7 @@
             <a:r>
               <a:rPr sz="1500" b="1">
                 <a:solidFill>
-                  <a:srgbClr val="0F172A"/>
+                  <a:srgbClr val="0E1729"/>
                 </a:solidFill>
                 <a:latin typeface="Arial"/>
                 <a:ea typeface="Arial"/>
@@ -6331,7 +6336,7 @@
             <a:avLst/>
           </a:prstGeom>
           <a:solidFill xmlns:a="http://schemas.openxmlformats.org/drawingml/2006/main">
-            <a:srgbClr val="0F172A"/>
+            <a:srgbClr val="0E1729"/>
           </a:solidFill>
         </p:spPr>
       </p:sp>
@@ -6405,7 +6410,7 @@
             </a:avLst>
           </a:prstGeom>
           <a:solidFill xmlns:a="http://schemas.openxmlformats.org/drawingml/2006/main">
-            <a:srgbClr val="F8FAFC"/>
+            <a:srgbClr val="FBFAF7"/>
           </a:solidFill>
           <a:ln xmlns:a="http://schemas.openxmlformats.org/drawingml/2006/main" w="12700">
             <a:solidFill>
@@ -6438,7 +6443,7 @@
             <a:avLst/>
           </a:prstGeom>
           <a:solidFill xmlns:a="http://schemas.openxmlformats.org/drawingml/2006/main">
-            <a:srgbClr val="0F172A"/>
+            <a:srgbClr val="0E1729"/>
           </a:solidFill>
         </p:spPr>
       </p:sp>
@@ -6451,7 +6456,7 @@
           <p:nvPr/>
         </p:nvPicPr>
         <p:blipFill>
-          <a:blip xmlns:r="http://schemas.openxmlformats.org/officeDocument/2006/relationships" xmlns:a="http://schemas.openxmlformats.org/drawingml/2006/main" r:embed="R3943a0ea0b944af4"/>
+          <a:blip xmlns:r="http://schemas.openxmlformats.org/officeDocument/2006/relationships" xmlns:a="http://schemas.openxmlformats.org/drawingml/2006/main" r:embed="R9ecdc98e8e684463"/>
           <a:stretch xmlns:a="http://schemas.openxmlformats.org/drawingml/2006/main">
             <a:fillRect l="0" t="0" r="0" b="0"/>
           </a:stretch>
@@ -6500,7 +6505,7 @@
             <a:r>
               <a:rPr sz="1500" b="1">
                 <a:solidFill>
-                  <a:srgbClr val="0F172A"/>
+                  <a:srgbClr val="0E1729"/>
                 </a:solidFill>
                 <a:latin typeface="Arial"/>
                 <a:ea typeface="Arial"/>
@@ -6595,7 +6600,7 @@
             <a:avLst/>
           </a:prstGeom>
           <a:solidFill xmlns:a="http://schemas.openxmlformats.org/drawingml/2006/main">
-            <a:srgbClr val="0F172A"/>
+            <a:srgbClr val="0E1729"/>
           </a:solidFill>
         </p:spPr>
       </p:sp>
@@ -6669,7 +6674,7 @@
             </a:avLst>
           </a:prstGeom>
           <a:solidFill xmlns:a="http://schemas.openxmlformats.org/drawingml/2006/main">
-            <a:srgbClr val="F8FAFC"/>
+            <a:srgbClr val="FBFAF7"/>
           </a:solidFill>
           <a:ln xmlns:a="http://schemas.openxmlformats.org/drawingml/2006/main" w="12700">
             <a:solidFill>
@@ -6702,7 +6707,7 @@
             <a:avLst/>
           </a:prstGeom>
           <a:solidFill xmlns:a="http://schemas.openxmlformats.org/drawingml/2006/main">
-            <a:srgbClr val="0F172A"/>
+            <a:srgbClr val="0E1729"/>
           </a:solidFill>
         </p:spPr>
       </p:sp>
@@ -6715,7 +6720,7 @@
           <p:nvPr/>
         </p:nvPicPr>
         <p:blipFill>
-          <a:blip xmlns:r="http://schemas.openxmlformats.org/officeDocument/2006/relationships" xmlns:a="http://schemas.openxmlformats.org/drawingml/2006/main" r:embed="Rf24c3ed40ea64803"/>
+          <a:blip xmlns:r="http://schemas.openxmlformats.org/officeDocument/2006/relationships" xmlns:a="http://schemas.openxmlformats.org/drawingml/2006/main" r:embed="R92a623455b954c88"/>
           <a:stretch xmlns:a="http://schemas.openxmlformats.org/drawingml/2006/main">
             <a:fillRect l="0" t="0" r="0" b="0"/>
           </a:stretch>
@@ -6764,7 +6769,7 @@
             <a:r>
               <a:rPr sz="1500" b="1">
                 <a:solidFill>
-                  <a:srgbClr val="0F172A"/>
+                  <a:srgbClr val="0E1729"/>
                 </a:solidFill>
                 <a:latin typeface="Arial"/>
                 <a:ea typeface="Arial"/>
@@ -6859,7 +6864,7 @@
             <a:avLst/>
           </a:prstGeom>
           <a:solidFill xmlns:a="http://schemas.openxmlformats.org/drawingml/2006/main">
-            <a:srgbClr val="F59E0B"/>
+            <a:srgbClr val="F5B335"/>
           </a:solidFill>
         </p:spPr>
       </p:sp>
@@ -6897,7 +6902,7 @@
             <a:r>
               <a:rPr sz="1600" b="1">
                 <a:solidFill>
-                  <a:srgbClr val="0F172A"/>
+                  <a:srgbClr val="0E1729"/>
                 </a:solidFill>
                 <a:latin typeface="Arial"/>
                 <a:ea typeface="Arial"/>
@@ -6933,7 +6938,7 @@
             </a:avLst>
           </a:prstGeom>
           <a:solidFill xmlns:a="http://schemas.openxmlformats.org/drawingml/2006/main">
-            <a:srgbClr val="F8FAFC"/>
+            <a:srgbClr val="FBFAF7"/>
           </a:solidFill>
           <a:ln xmlns:a="http://schemas.openxmlformats.org/drawingml/2006/main" w="12700">
             <a:solidFill>
@@ -6966,7 +6971,7 @@
             <a:avLst/>
           </a:prstGeom>
           <a:solidFill xmlns:a="http://schemas.openxmlformats.org/drawingml/2006/main">
-            <a:srgbClr val="F59E0B"/>
+            <a:srgbClr val="F5B335"/>
           </a:solidFill>
         </p:spPr>
       </p:sp>
@@ -6979,7 +6984,7 @@
           <p:nvPr/>
         </p:nvPicPr>
         <p:blipFill>
-          <a:blip xmlns:r="http://schemas.openxmlformats.org/officeDocument/2006/relationships" xmlns:a="http://schemas.openxmlformats.org/drawingml/2006/main" r:embed="Ree01eb4500ae4f25"/>
+          <a:blip xmlns:r="http://schemas.openxmlformats.org/officeDocument/2006/relationships" xmlns:a="http://schemas.openxmlformats.org/drawingml/2006/main" r:embed="R74a2f0dddece4a50"/>
           <a:stretch xmlns:a="http://schemas.openxmlformats.org/drawingml/2006/main">
             <a:fillRect l="0" t="0" r="0" b="0"/>
           </a:stretch>
@@ -7028,7 +7033,7 @@
             <a:r>
               <a:rPr sz="1500" b="1">
                 <a:solidFill>
-                  <a:srgbClr val="0F172A"/>
+                  <a:srgbClr val="0E1729"/>
                 </a:solidFill>
                 <a:latin typeface="Arial"/>
                 <a:ea typeface="Arial"/>
@@ -7125,7 +7130,7 @@
             </a:avLst>
           </a:prstGeom>
           <a:solidFill xmlns:a="http://schemas.openxmlformats.org/drawingml/2006/main">
-            <a:srgbClr val="F1F5F9"/>
+            <a:srgbClr val="F7F5F2"/>
           </a:solidFill>
         </p:spPr>
       </p:sp>
@@ -7163,7 +7168,7 @@
             <a:r>
               <a:rPr sz="1250" b="1">
                 <a:solidFill>
-                  <a:srgbClr val="0F172A"/>
+                  <a:srgbClr val="0E1729"/>
                 </a:solidFill>
                 <a:latin typeface="Arial"/>
                 <a:ea typeface="Arial"/>
@@ -7174,7 +7179,7 @@
             <a:r>
               <a:rPr sz="1150">
                 <a:solidFill>
-                  <a:srgbClr val="475569"/>
+                  <a:srgbClr val="0E1729"/>
                 </a:solidFill>
                 <a:latin typeface="Arial"/>
                 <a:ea typeface="Arial"/>
@@ -7201,7 +7206,7 @@
     <p:bg>
       <p:bgPr>
         <a:solidFill xmlns:a="http://schemas.openxmlformats.org/drawingml/2006/main">
-          <a:srgbClr val="0F172A"/>
+          <a:srgbClr val="0E1729"/>
         </a:solidFill>
       </p:bgPr>
     </p:bg>
@@ -7303,17 +7308,15 @@
       </p:sp>
       <p:pic>
         <p:nvPicPr>
-          <p:cNvPr id="20" name="Image 0"/>
+          <p:cNvPr id="21" name="Image 0"/>
           <p:cNvPicPr>
             <a:picLocks xmlns:a="http://schemas.openxmlformats.org/drawingml/2006/main" noChangeAspect="1"/>
           </p:cNvPicPr>
           <p:nvPr/>
         </p:nvPicPr>
         <p:blipFill>
-          <a:blip xmlns:r="http://schemas.openxmlformats.org/officeDocument/2006/relationships" xmlns:a="http://schemas.openxmlformats.org/drawingml/2006/main" r:embed="Re3ce2f0f0c2c45d6"/>
-          <a:stretch xmlns:a="http://schemas.openxmlformats.org/drawingml/2006/main">
-            <a:fillRect l="0" t="0" r="0" b="0"/>
-          </a:stretch>
+          <a:blip xmlns:r="http://schemas.openxmlformats.org/officeDocument/2006/relationships" xmlns:a="http://schemas.openxmlformats.org/drawingml/2006/main" r:embed="R5f467d9c62ee4414"/>
+          <a:stretch xmlns:a="http://schemas.openxmlformats.org/drawingml/2006/main"/>
         </p:blipFill>
         <p:spPr>
           <a:xfrm xmlns:a="http://schemas.openxmlformats.org/drawingml/2006/main">
@@ -7359,7 +7362,7 @@
             <a:r>
               <a:rPr sz="3800" b="1">
                 <a:solidFill>
-                  <a:srgbClr val="F8FAFC"/>
+                  <a:srgbClr val="FFFFFF"/>
                 </a:solidFill>
                 <a:latin typeface="Arial"/>
                 <a:ea typeface="Arial"/>
@@ -7438,7 +7441,7 @@
             <a:avLst/>
           </a:prstGeom>
           <a:solidFill xmlns:a="http://schemas.openxmlformats.org/drawingml/2006/main">
-            <a:srgbClr val="FBBF24"/>
+            <a:srgbClr val="F5B335"/>
           </a:solidFill>
         </p:spPr>
       </p:sp>
@@ -7521,7 +7524,7 @@
             <a:avLst/>
           </a:prstGeom>
           <a:solidFill xmlns:a="http://schemas.openxmlformats.org/drawingml/2006/main">
-            <a:srgbClr val="FBBF24"/>
+            <a:srgbClr val="F5B335"/>
           </a:solidFill>
         </p:spPr>
       </p:sp>
@@ -7576,7 +7579,7 @@
                 <a:ea typeface="Arial"/>
                 <a:cs typeface="Arial"/>
               </a:rPr>
-              <a:t>［商务邮箱 · 待补充］</a:t>
+              <a:t>请通过演示邀约渠道联系</a:t>
             </a:r>
           </a:p>
         </p:txBody>
@@ -7604,7 +7607,7 @@
             <a:avLst/>
           </a:prstGeom>
           <a:solidFill xmlns:a="http://schemas.openxmlformats.org/drawingml/2006/main">
-            <a:srgbClr val="FBBF24"/>
+            <a:srgbClr val="F5B335"/>
           </a:solidFill>
         </p:spPr>
       </p:sp>
@@ -7709,51 +7712,28 @@
           </a:p>
         </p:txBody>
       </p:sp>
-      <p:sp>
-        <p:nvSpPr>
-          <p:cNvPr id="15" name="Text 12">
-            <a:extLst xmlns:a="http://schemas.openxmlformats.org/drawingml/2006/main">
-              <a:ext uri="{FF2B5EF4-FFF2-40B4-BE49-F238E27FC236}">
-                <a16:creationId xmlns:a16="http://schemas.microsoft.com/office/drawing/2014/main" id="{6C5EAE8D-34A7-4755-A268-A26D94D6924E}"/>
-              </a:ext>
-            </a:extLst>
-          </p:cNvPr>
-          <p:cNvSpPr>
-            <a:spLocks xmlns:a="http://schemas.openxmlformats.org/drawingml/2006/main" noGrp="1"/>
-          </p:cNvSpPr>
-          <p:nvPr/>
-        </p:nvSpPr>
-        <p:spPr>
-          <a:xfrm xmlns:a="http://schemas.openxmlformats.org/drawingml/2006/main">
-            <a:off x="6976872" y="6281928"/>
-            <a:ext cx="4389120" cy="237744"/>
-          </a:xfrm>
-          <a:prstGeom xmlns:a="http://schemas.openxmlformats.org/drawingml/2006/main" prst="rect">
-            <a:avLst/>
-          </a:prstGeom>
-          <a:noFill xmlns:a="http://schemas.openxmlformats.org/drawingml/2006/main"/>
-        </p:spPr>
-        <p:txBody>
-          <a:bodyPr xmlns:a="http://schemas.openxmlformats.org/drawingml/2006/main" wrap="square" lIns="0" tIns="0" rIns="0" bIns="0" anchor="ctr"/>
-          <a:lstStyle xmlns:a="http://schemas.openxmlformats.org/drawingml/2006/main"/>
-          <a:p xmlns:a="http://schemas.openxmlformats.org/drawingml/2006/main">
-            <a:pPr marL="0" indent="0" algn="r">
-              <a:buNone/>
-            </a:pPr>
-            <a:r>
-              <a:rPr sz="800" b="1">
-                <a:solidFill>
-                  <a:srgbClr val="94A3B8"/>
-                </a:solidFill>
-                <a:latin typeface="Arial"/>
-                <a:ea typeface="Arial"/>
-                <a:cs typeface="Arial"/>
-              </a:rPr>
-              <a:t>A PARADISE PRODUCTION · 天域文创出品</a:t>
-            </a:r>
-          </a:p>
-        </p:txBody>
-      </p:sp>
+      <p:pic>
+        <p:nvPicPr>
+          <p:cNvPr id="31" name=""/>
+          <p:cNvPicPr>
+            <a:picLocks xmlns:a="http://schemas.openxmlformats.org/drawingml/2006/main" noChangeAspect="1"/>
+          </p:cNvPicPr>
+          <p:nvPr/>
+        </p:nvPicPr>
+        <p:blipFill>
+          <a:blip xmlns:r="http://schemas.openxmlformats.org/officeDocument/2006/relationships" xmlns:a="http://schemas.openxmlformats.org/drawingml/2006/main" r:embed="R19114e500a8e4047"/>
+          <a:stretch xmlns:a="http://schemas.openxmlformats.org/drawingml/2006/main"/>
+        </p:blipFill>
+        <p:spPr>
+          <a:xfrm xmlns:a="http://schemas.openxmlformats.org/drawingml/2006/main">
+            <a:off x="8763000" y="5963841"/>
+            <a:ext cx="2590800" cy="607219"/>
+          </a:xfrm>
+          <a:prstGeom xmlns:a="http://schemas.openxmlformats.org/drawingml/2006/main" prst="rect">
+            <a:avLst/>
+          </a:prstGeom>
+        </p:spPr>
+      </p:pic>
     </p:spTree>
     <p:extLst>
       <p:ext uri="{BB962C8B-B14F-4D97-AF65-F5344CB8AC3E}">
@@ -7806,7 +7786,7 @@
             <a:avLst/>
           </a:prstGeom>
           <a:solidFill xmlns:a="http://schemas.openxmlformats.org/drawingml/2006/main">
-            <a:srgbClr val="F59E0B"/>
+            <a:srgbClr val="F5B335"/>
           </a:solidFill>
         </p:spPr>
       </p:sp>
@@ -7889,7 +7869,7 @@
             <a:r>
               <a:rPr sz="2700" b="1">
                 <a:solidFill>
-                  <a:srgbClr val="0F172A"/>
+                  <a:srgbClr val="0E1729"/>
                 </a:solidFill>
                 <a:latin typeface="Arial"/>
                 <a:ea typeface="Arial"/>
@@ -7982,7 +7962,7 @@
             <a:r>
               <a:rPr sz="1600" b="1">
                 <a:solidFill>
-                  <a:srgbClr val="1E293B"/>
+                  <a:srgbClr val="16233D"/>
                 </a:solidFill>
                 <a:latin typeface="Arial"/>
                 <a:ea typeface="Arial"/>
@@ -8036,7 +8016,7 @@
             <a:r>
               <a:rPr sz="1300" b="1">
                 <a:solidFill>
-                  <a:srgbClr val="0F172A"/>
+                  <a:srgbClr val="0E1729"/>
                 </a:solidFill>
                 <a:latin typeface="Arial"/>
                 <a:ea typeface="Arial"/>
@@ -8072,7 +8052,7 @@
             </a:avLst>
           </a:prstGeom>
           <a:solidFill xmlns:a="http://schemas.openxmlformats.org/drawingml/2006/main">
-            <a:srgbClr val="F1F5F9"/>
+            <a:srgbClr val="F7F5F2"/>
           </a:solidFill>
         </p:spPr>
       </p:sp>
@@ -8099,7 +8079,7 @@
             <a:avLst/>
           </a:prstGeom>
           <a:solidFill xmlns:a="http://schemas.openxmlformats.org/drawingml/2006/main">
-            <a:srgbClr val="0F172A"/>
+            <a:srgbClr val="0E1729"/>
           </a:solidFill>
         </p:spPr>
       </p:sp>
@@ -8112,7 +8092,7 @@
           <p:nvPr/>
         </p:nvPicPr>
         <p:blipFill>
-          <a:blip xmlns:r="http://schemas.openxmlformats.org/officeDocument/2006/relationships" xmlns:a="http://schemas.openxmlformats.org/drawingml/2006/main" r:embed="Rd9364bb3e7f64fb6"/>
+          <a:blip xmlns:r="http://schemas.openxmlformats.org/officeDocument/2006/relationships" xmlns:a="http://schemas.openxmlformats.org/drawingml/2006/main" r:embed="R91067ae6957b4ba6"/>
           <a:stretch xmlns:a="http://schemas.openxmlformats.org/drawingml/2006/main">
             <a:fillRect l="0" t="0" r="0" b="0"/>
           </a:stretch>
@@ -8161,7 +8141,7 @@
             <a:r>
               <a:rPr sz="1450" b="1">
                 <a:solidFill>
-                  <a:srgbClr val="0F172A"/>
+                  <a:srgbClr val="0E1729"/>
                 </a:solidFill>
                 <a:latin typeface="Arial"/>
                 <a:ea typeface="Arial"/>
@@ -8258,7 +8238,7 @@
             </a:avLst>
           </a:prstGeom>
           <a:solidFill xmlns:a="http://schemas.openxmlformats.org/drawingml/2006/main">
-            <a:srgbClr val="F1F5F9"/>
+            <a:srgbClr val="F7F5F2"/>
           </a:solidFill>
         </p:spPr>
       </p:sp>
@@ -8285,7 +8265,7 @@
             <a:avLst/>
           </a:prstGeom>
           <a:solidFill xmlns:a="http://schemas.openxmlformats.org/drawingml/2006/main">
-            <a:srgbClr val="0F172A"/>
+            <a:srgbClr val="0E1729"/>
           </a:solidFill>
         </p:spPr>
       </p:sp>
@@ -8298,7 +8278,7 @@
           <p:nvPr/>
         </p:nvPicPr>
         <p:blipFill>
-          <a:blip xmlns:r="http://schemas.openxmlformats.org/officeDocument/2006/relationships" xmlns:a="http://schemas.openxmlformats.org/drawingml/2006/main" r:embed="R26fc93d1ef9a404a"/>
+          <a:blip xmlns:r="http://schemas.openxmlformats.org/officeDocument/2006/relationships" xmlns:a="http://schemas.openxmlformats.org/drawingml/2006/main" r:embed="Rf6bc23125f4c4f14"/>
           <a:stretch xmlns:a="http://schemas.openxmlformats.org/drawingml/2006/main">
             <a:fillRect l="0" t="0" r="0" b="0"/>
           </a:stretch>
@@ -8347,7 +8327,7 @@
             <a:r>
               <a:rPr sz="1450" b="1">
                 <a:solidFill>
-                  <a:srgbClr val="0F172A"/>
+                  <a:srgbClr val="0E1729"/>
                 </a:solidFill>
                 <a:latin typeface="Arial"/>
                 <a:ea typeface="Arial"/>
@@ -8444,7 +8424,7 @@
             </a:avLst>
           </a:prstGeom>
           <a:solidFill xmlns:a="http://schemas.openxmlformats.org/drawingml/2006/main">
-            <a:srgbClr val="F1F5F9"/>
+            <a:srgbClr val="F7F5F2"/>
           </a:solidFill>
         </p:spPr>
       </p:sp>
@@ -8471,7 +8451,7 @@
             <a:avLst/>
           </a:prstGeom>
           <a:solidFill xmlns:a="http://schemas.openxmlformats.org/drawingml/2006/main">
-            <a:srgbClr val="0F172A"/>
+            <a:srgbClr val="0E1729"/>
           </a:solidFill>
         </p:spPr>
       </p:sp>
@@ -8484,7 +8464,7 @@
           <p:nvPr/>
         </p:nvPicPr>
         <p:blipFill>
-          <a:blip xmlns:r="http://schemas.openxmlformats.org/officeDocument/2006/relationships" xmlns:a="http://schemas.openxmlformats.org/drawingml/2006/main" r:embed="R8ba7c1d679db4c0c"/>
+          <a:blip xmlns:r="http://schemas.openxmlformats.org/officeDocument/2006/relationships" xmlns:a="http://schemas.openxmlformats.org/drawingml/2006/main" r:embed="R4c5b12ea6e56497b"/>
           <a:stretch xmlns:a="http://schemas.openxmlformats.org/drawingml/2006/main">
             <a:fillRect l="0" t="0" r="0" b="0"/>
           </a:stretch>
@@ -8533,7 +8513,7 @@
             <a:r>
               <a:rPr sz="1450" b="1">
                 <a:solidFill>
-                  <a:srgbClr val="0F172A"/>
+                  <a:srgbClr val="0E1729"/>
                 </a:solidFill>
                 <a:latin typeface="Arial"/>
                 <a:ea typeface="Arial"/>
@@ -8630,7 +8610,7 @@
             </a:avLst>
           </a:prstGeom>
           <a:solidFill xmlns:a="http://schemas.openxmlformats.org/drawingml/2006/main">
-            <a:srgbClr val="F1F5F9"/>
+            <a:srgbClr val="F7F5F2"/>
           </a:solidFill>
         </p:spPr>
       </p:sp>
@@ -8657,7 +8637,7 @@
             <a:avLst/>
           </a:prstGeom>
           <a:solidFill xmlns:a="http://schemas.openxmlformats.org/drawingml/2006/main">
-            <a:srgbClr val="0F172A"/>
+            <a:srgbClr val="0E1729"/>
           </a:solidFill>
         </p:spPr>
       </p:sp>
@@ -8670,7 +8650,7 @@
           <p:nvPr/>
         </p:nvPicPr>
         <p:blipFill>
-          <a:blip xmlns:r="http://schemas.openxmlformats.org/officeDocument/2006/relationships" xmlns:a="http://schemas.openxmlformats.org/drawingml/2006/main" r:embed="R268234d997354144"/>
+          <a:blip xmlns:r="http://schemas.openxmlformats.org/officeDocument/2006/relationships" xmlns:a="http://schemas.openxmlformats.org/drawingml/2006/main" r:embed="R7015839f6c844236"/>
           <a:stretch xmlns:a="http://schemas.openxmlformats.org/drawingml/2006/main">
             <a:fillRect l="0" t="0" r="0" b="0"/>
           </a:stretch>
@@ -8719,7 +8699,7 @@
             <a:r>
               <a:rPr sz="1450" b="1">
                 <a:solidFill>
-                  <a:srgbClr val="0F172A"/>
+                  <a:srgbClr val="0E1729"/>
                 </a:solidFill>
                 <a:latin typeface="Arial"/>
                 <a:ea typeface="Arial"/>
@@ -8843,7 +8823,7 @@
             <a:avLst/>
           </a:prstGeom>
           <a:solidFill xmlns:a="http://schemas.openxmlformats.org/drawingml/2006/main">
-            <a:srgbClr val="F59E0B"/>
+            <a:srgbClr val="F5B335"/>
           </a:solidFill>
         </p:spPr>
       </p:sp>
@@ -8926,7 +8906,7 @@
             <a:r>
               <a:rPr sz="2700" b="1">
                 <a:solidFill>
-                  <a:srgbClr val="0F172A"/>
+                  <a:srgbClr val="0E1729"/>
                 </a:solidFill>
                 <a:latin typeface="Arial"/>
                 <a:ea typeface="Arial"/>
@@ -9007,7 +8987,7 @@
             </a:avLst>
           </a:prstGeom>
           <a:solidFill xmlns:a="http://schemas.openxmlformats.org/drawingml/2006/main">
-            <a:srgbClr val="F8FAFC"/>
+            <a:srgbClr val="FBFAF7"/>
           </a:solidFill>
           <a:ln xmlns:a="http://schemas.openxmlformats.org/drawingml/2006/main" w="12700">
             <a:solidFill>
@@ -9040,7 +9020,7 @@
             <a:avLst/>
           </a:prstGeom>
           <a:solidFill xmlns:a="http://schemas.openxmlformats.org/drawingml/2006/main">
-            <a:srgbClr val="0F172A"/>
+            <a:srgbClr val="0E1729"/>
           </a:solidFill>
         </p:spPr>
       </p:sp>
@@ -9053,7 +9033,7 @@
           <p:nvPr/>
         </p:nvPicPr>
         <p:blipFill>
-          <a:blip xmlns:r="http://schemas.openxmlformats.org/officeDocument/2006/relationships" xmlns:a="http://schemas.openxmlformats.org/drawingml/2006/main" r:embed="R6a0969d13ff74746"/>
+          <a:blip xmlns:r="http://schemas.openxmlformats.org/officeDocument/2006/relationships" xmlns:a="http://schemas.openxmlformats.org/drawingml/2006/main" r:embed="Ra9fefdb5579c4820"/>
           <a:stretch xmlns:a="http://schemas.openxmlformats.org/drawingml/2006/main">
             <a:fillRect l="0" t="0" r="0" b="0"/>
           </a:stretch>
@@ -9102,7 +9082,7 @@
             <a:r>
               <a:rPr sz="1400" b="1">
                 <a:solidFill>
-                  <a:srgbClr val="0F172A"/>
+                  <a:srgbClr val="0E1729"/>
                 </a:solidFill>
                 <a:latin typeface="Arial"/>
                 <a:ea typeface="Arial"/>
@@ -9272,7 +9252,7 @@
             </a:avLst>
           </a:prstGeom>
           <a:solidFill xmlns:a="http://schemas.openxmlformats.org/drawingml/2006/main">
-            <a:srgbClr val="F8FAFC"/>
+            <a:srgbClr val="FBFAF7"/>
           </a:solidFill>
           <a:ln xmlns:a="http://schemas.openxmlformats.org/drawingml/2006/main" w="12700">
             <a:solidFill>
@@ -9305,7 +9285,7 @@
             <a:avLst/>
           </a:prstGeom>
           <a:solidFill xmlns:a="http://schemas.openxmlformats.org/drawingml/2006/main">
-            <a:srgbClr val="0F172A"/>
+            <a:srgbClr val="0E1729"/>
           </a:solidFill>
         </p:spPr>
       </p:sp>
@@ -9318,7 +9298,7 @@
           <p:nvPr/>
         </p:nvPicPr>
         <p:blipFill>
-          <a:blip xmlns:r="http://schemas.openxmlformats.org/officeDocument/2006/relationships" xmlns:a="http://schemas.openxmlformats.org/drawingml/2006/main" r:embed="R401658d6d72f4624"/>
+          <a:blip xmlns:r="http://schemas.openxmlformats.org/officeDocument/2006/relationships" xmlns:a="http://schemas.openxmlformats.org/drawingml/2006/main" r:embed="R79f158c6c72a49ae"/>
           <a:stretch xmlns:a="http://schemas.openxmlformats.org/drawingml/2006/main">
             <a:fillRect l="0" t="0" r="0" b="0"/>
           </a:stretch>
@@ -9367,7 +9347,7 @@
             <a:r>
               <a:rPr sz="1400" b="1">
                 <a:solidFill>
-                  <a:srgbClr val="0F172A"/>
+                  <a:srgbClr val="0E1729"/>
                 </a:solidFill>
                 <a:latin typeface="Arial"/>
                 <a:ea typeface="Arial"/>
@@ -9537,7 +9517,7 @@
             </a:avLst>
           </a:prstGeom>
           <a:solidFill xmlns:a="http://schemas.openxmlformats.org/drawingml/2006/main">
-            <a:srgbClr val="F8FAFC"/>
+            <a:srgbClr val="FBFAF7"/>
           </a:solidFill>
           <a:ln xmlns:a="http://schemas.openxmlformats.org/drawingml/2006/main" w="12700">
             <a:solidFill>
@@ -9570,7 +9550,7 @@
             <a:avLst/>
           </a:prstGeom>
           <a:solidFill xmlns:a="http://schemas.openxmlformats.org/drawingml/2006/main">
-            <a:srgbClr val="0F172A"/>
+            <a:srgbClr val="0E1729"/>
           </a:solidFill>
         </p:spPr>
       </p:sp>
@@ -9583,7 +9563,7 @@
           <p:nvPr/>
         </p:nvPicPr>
         <p:blipFill>
-          <a:blip xmlns:r="http://schemas.openxmlformats.org/officeDocument/2006/relationships" xmlns:a="http://schemas.openxmlformats.org/drawingml/2006/main" r:embed="Rf61ff93871e345a8"/>
+          <a:blip xmlns:r="http://schemas.openxmlformats.org/officeDocument/2006/relationships" xmlns:a="http://schemas.openxmlformats.org/drawingml/2006/main" r:embed="R1a9242cf7dd04240"/>
           <a:stretch xmlns:a="http://schemas.openxmlformats.org/drawingml/2006/main">
             <a:fillRect l="0" t="0" r="0" b="0"/>
           </a:stretch>
@@ -9632,7 +9612,7 @@
             <a:r>
               <a:rPr sz="1400" b="1">
                 <a:solidFill>
-                  <a:srgbClr val="0F172A"/>
+                  <a:srgbClr val="0E1729"/>
                 </a:solidFill>
                 <a:latin typeface="Arial"/>
                 <a:ea typeface="Arial"/>
@@ -9802,7 +9782,7 @@
             </a:avLst>
           </a:prstGeom>
           <a:solidFill xmlns:a="http://schemas.openxmlformats.org/drawingml/2006/main">
-            <a:srgbClr val="F8FAFC"/>
+            <a:srgbClr val="FBFAF7"/>
           </a:solidFill>
           <a:ln xmlns:a="http://schemas.openxmlformats.org/drawingml/2006/main" w="12700">
             <a:solidFill>
@@ -9835,7 +9815,7 @@
             <a:avLst/>
           </a:prstGeom>
           <a:solidFill xmlns:a="http://schemas.openxmlformats.org/drawingml/2006/main">
-            <a:srgbClr val="F59E0B"/>
+            <a:srgbClr val="F5B335"/>
           </a:solidFill>
         </p:spPr>
       </p:sp>
@@ -9848,7 +9828,7 @@
           <p:nvPr/>
         </p:nvPicPr>
         <p:blipFill>
-          <a:blip xmlns:r="http://schemas.openxmlformats.org/officeDocument/2006/relationships" xmlns:a="http://schemas.openxmlformats.org/drawingml/2006/main" r:embed="R9f8da8078d294cde"/>
+          <a:blip xmlns:r="http://schemas.openxmlformats.org/officeDocument/2006/relationships" xmlns:a="http://schemas.openxmlformats.org/drawingml/2006/main" r:embed="R19d9e7d653b14bc9"/>
           <a:stretch xmlns:a="http://schemas.openxmlformats.org/drawingml/2006/main">
             <a:fillRect l="0" t="0" r="0" b="0"/>
           </a:stretch>
@@ -9897,7 +9877,7 @@
             <a:r>
               <a:rPr sz="1400" b="1">
                 <a:solidFill>
-                  <a:srgbClr val="0F172A"/>
+                  <a:srgbClr val="0E1729"/>
                 </a:solidFill>
                 <a:latin typeface="Arial"/>
                 <a:ea typeface="Arial"/>
@@ -10067,7 +10047,7 @@
             </a:avLst>
           </a:prstGeom>
           <a:solidFill xmlns:a="http://schemas.openxmlformats.org/drawingml/2006/main">
-            <a:srgbClr val="0F172A"/>
+            <a:srgbClr val="0E1729"/>
           </a:solidFill>
         </p:spPr>
       </p:sp>
@@ -10094,7 +10074,7 @@
             <a:avLst/>
           </a:prstGeom>
           <a:solidFill xmlns:a="http://schemas.openxmlformats.org/drawingml/2006/main">
-            <a:srgbClr val="334155"/>
+            <a:srgbClr val="22355A"/>
           </a:solidFill>
         </p:spPr>
       </p:sp>
@@ -10107,7 +10087,7 @@
           <p:nvPr/>
         </p:nvPicPr>
         <p:blipFill>
-          <a:blip xmlns:r="http://schemas.openxmlformats.org/officeDocument/2006/relationships" xmlns:a="http://schemas.openxmlformats.org/drawingml/2006/main" r:embed="Rbda0f5a4281540ac"/>
+          <a:blip xmlns:r="http://schemas.openxmlformats.org/officeDocument/2006/relationships" xmlns:a="http://schemas.openxmlformats.org/drawingml/2006/main" r:embed="R981cc80b576b4c2e"/>
           <a:stretch xmlns:a="http://schemas.openxmlformats.org/drawingml/2006/main">
             <a:fillRect l="0" t="0" r="0" b="0"/>
           </a:stretch>
@@ -10264,7 +10244,7 @@
             <a:avLst/>
           </a:prstGeom>
           <a:solidFill xmlns:a="http://schemas.openxmlformats.org/drawingml/2006/main">
-            <a:srgbClr val="F59E0B"/>
+            <a:srgbClr val="F5B335"/>
           </a:solidFill>
         </p:spPr>
       </p:sp>
@@ -10347,7 +10327,7 @@
             <a:r>
               <a:rPr sz="2700" b="1">
                 <a:solidFill>
-                  <a:srgbClr val="0F172A"/>
+                  <a:srgbClr val="0E1729"/>
                 </a:solidFill>
                 <a:latin typeface="Arial"/>
                 <a:ea typeface="Arial"/>
@@ -10441,7 +10421,7 @@
             <a:r>
               <a:rPr sz="1350" b="1">
                 <a:solidFill>
-                  <a:srgbClr val="0F172A"/>
+                  <a:srgbClr val="0E1729"/>
                 </a:solidFill>
                 <a:latin typeface="Arial"/>
                 <a:ea typeface="Arial"/>
@@ -10460,7 +10440,7 @@
             <a:r>
               <a:rPr sz="1150">
                 <a:solidFill>
-                  <a:srgbClr val="64748B"/>
+                  <a:srgbClr val="0E1729"/>
                 </a:solidFill>
                 <a:latin typeface="Arial"/>
                 <a:ea typeface="Arial"/>
@@ -10480,7 +10460,7 @@
             <a:r>
               <a:rPr sz="1350" b="1">
                 <a:solidFill>
-                  <a:srgbClr val="0F172A"/>
+                  <a:srgbClr val="0E1729"/>
                 </a:solidFill>
                 <a:latin typeface="Arial"/>
                 <a:ea typeface="Arial"/>
@@ -10499,7 +10479,7 @@
             <a:r>
               <a:rPr sz="1150">
                 <a:solidFill>
-                  <a:srgbClr val="64748B"/>
+                  <a:srgbClr val="0E1729"/>
                 </a:solidFill>
                 <a:latin typeface="Arial"/>
                 <a:ea typeface="Arial"/>
@@ -10519,7 +10499,7 @@
             <a:r>
               <a:rPr sz="1350" b="1">
                 <a:solidFill>
-                  <a:srgbClr val="0F172A"/>
+                  <a:srgbClr val="0E1729"/>
                 </a:solidFill>
                 <a:latin typeface="Arial"/>
                 <a:ea typeface="Arial"/>
@@ -10538,7 +10518,7 @@
             <a:r>
               <a:rPr sz="1150">
                 <a:solidFill>
-                  <a:srgbClr val="64748B"/>
+                  <a:srgbClr val="0E1729"/>
                 </a:solidFill>
                 <a:latin typeface="Arial"/>
                 <a:ea typeface="Arial"/>
@@ -10558,7 +10538,7 @@
             <a:r>
               <a:rPr sz="1350" b="1">
                 <a:solidFill>
-                  <a:srgbClr val="0F172A"/>
+                  <a:srgbClr val="0E1729"/>
                 </a:solidFill>
                 <a:latin typeface="Arial"/>
                 <a:ea typeface="Arial"/>
@@ -10577,7 +10557,7 @@
             <a:r>
               <a:rPr sz="1150">
                 <a:solidFill>
-                  <a:srgbClr val="64748B"/>
+                  <a:srgbClr val="0E1729"/>
                 </a:solidFill>
                 <a:latin typeface="Arial"/>
                 <a:ea typeface="Arial"/>
@@ -10597,7 +10577,7 @@
             <a:r>
               <a:rPr sz="1350" b="1">
                 <a:solidFill>
-                  <a:srgbClr val="0F172A"/>
+                  <a:srgbClr val="0E1729"/>
                 </a:solidFill>
                 <a:latin typeface="Arial"/>
                 <a:ea typeface="Arial"/>
@@ -10616,7 +10596,7 @@
             <a:r>
               <a:rPr sz="1150">
                 <a:solidFill>
-                  <a:srgbClr val="64748B"/>
+                  <a:srgbClr val="0E1729"/>
                 </a:solidFill>
                 <a:latin typeface="Arial"/>
                 <a:ea typeface="Arial"/>
@@ -10692,7 +10672,7 @@
             <a:avLst/>
           </a:prstGeom>
           <a:solidFill xmlns:a="http://schemas.openxmlformats.org/drawingml/2006/main">
-            <a:srgbClr val="F1F5F9"/>
+            <a:srgbClr val="F7F5F2"/>
           </a:solidFill>
         </p:spPr>
       </p:sp>
@@ -10845,7 +10825,7 @@
             <a:avLst/>
           </a:prstGeom>
           <a:solidFill xmlns:a="http://schemas.openxmlformats.org/drawingml/2006/main">
-            <a:srgbClr val="0F172A"/>
+            <a:srgbClr val="0E1729"/>
           </a:solidFill>
         </p:spPr>
       </p:sp>
@@ -10964,7 +10944,7 @@
             </a:avLst>
           </a:prstGeom>
           <a:solidFill xmlns:a="http://schemas.openxmlformats.org/drawingml/2006/main">
-            <a:srgbClr val="F59E0B"/>
+            <a:srgbClr val="F5B335"/>
           </a:solidFill>
         </p:spPr>
       </p:sp>
@@ -11002,7 +10982,7 @@
             <a:r>
               <a:rPr sz="1050" b="1">
                 <a:solidFill>
-                  <a:srgbClr val="0F172A"/>
+                  <a:srgbClr val="0E1729"/>
                 </a:solidFill>
                 <a:latin typeface="Arial"/>
                 <a:ea typeface="Arial"/>
@@ -11038,7 +11018,7 @@
             </a:avLst>
           </a:prstGeom>
           <a:solidFill xmlns:a="http://schemas.openxmlformats.org/drawingml/2006/main">
-            <a:srgbClr val="F8FAFC"/>
+            <a:srgbClr val="FBFAF7"/>
           </a:solidFill>
           <a:ln xmlns:a="http://schemas.openxmlformats.org/drawingml/2006/main" w="12700">
             <a:solidFill>
@@ -11071,7 +11051,7 @@
             <a:avLst/>
           </a:prstGeom>
           <a:solidFill xmlns:a="http://schemas.openxmlformats.org/drawingml/2006/main">
-            <a:srgbClr val="F1F5F9"/>
+            <a:srgbClr val="F7F5F2"/>
           </a:solidFill>
         </p:spPr>
       </p:sp>
@@ -11109,7 +11089,7 @@
             <a:r>
               <a:rPr sz="950" b="1">
                 <a:solidFill>
-                  <a:srgbClr val="1E293B"/>
+                  <a:srgbClr val="16233D"/>
                 </a:solidFill>
                 <a:latin typeface="Arial"/>
                 <a:ea typeface="Arial"/>
@@ -11145,7 +11125,7 @@
             </a:avLst>
           </a:prstGeom>
           <a:solidFill xmlns:a="http://schemas.openxmlformats.org/drawingml/2006/main">
-            <a:srgbClr val="F8FAFC"/>
+            <a:srgbClr val="FBFAF7"/>
           </a:solidFill>
           <a:ln xmlns:a="http://schemas.openxmlformats.org/drawingml/2006/main" w="12700">
             <a:solidFill>
@@ -11216,7 +11196,7 @@
             <a:r>
               <a:rPr sz="950" b="1">
                 <a:solidFill>
-                  <a:srgbClr val="1E293B"/>
+                  <a:srgbClr val="16233D"/>
                 </a:solidFill>
                 <a:latin typeface="Arial"/>
                 <a:ea typeface="Arial"/>
@@ -11252,7 +11232,7 @@
             </a:avLst>
           </a:prstGeom>
           <a:solidFill xmlns:a="http://schemas.openxmlformats.org/drawingml/2006/main">
-            <a:srgbClr val="F8FAFC"/>
+            <a:srgbClr val="FBFAF7"/>
           </a:solidFill>
           <a:ln xmlns:a="http://schemas.openxmlformats.org/drawingml/2006/main" w="12700">
             <a:solidFill>
@@ -11285,7 +11265,7 @@
             <a:avLst/>
           </a:prstGeom>
           <a:solidFill xmlns:a="http://schemas.openxmlformats.org/drawingml/2006/main">
-            <a:srgbClr val="F1F5F9"/>
+            <a:srgbClr val="F7F5F2"/>
           </a:solidFill>
         </p:spPr>
       </p:sp>
@@ -11323,7 +11303,7 @@
             <a:r>
               <a:rPr sz="950" b="1">
                 <a:solidFill>
-                  <a:srgbClr val="1E293B"/>
+                  <a:srgbClr val="16233D"/>
                 </a:solidFill>
                 <a:latin typeface="Arial"/>
                 <a:ea typeface="Arial"/>
@@ -11359,7 +11339,7 @@
             </a:avLst>
           </a:prstGeom>
           <a:solidFill xmlns:a="http://schemas.openxmlformats.org/drawingml/2006/main">
-            <a:srgbClr val="F1F5F9"/>
+            <a:srgbClr val="F7F5F2"/>
           </a:solidFill>
         </p:spPr>
       </p:sp>
@@ -11386,7 +11366,7 @@
             <a:avLst/>
           </a:prstGeom>
           <a:solidFill xmlns:a="http://schemas.openxmlformats.org/drawingml/2006/main">
-            <a:srgbClr val="0F172A"/>
+            <a:srgbClr val="0E1729"/>
           </a:solidFill>
         </p:spPr>
       </p:sp>
@@ -11399,7 +11379,7 @@
           <p:nvPr/>
         </p:nvPicPr>
         <p:blipFill>
-          <a:blip xmlns:r="http://schemas.openxmlformats.org/officeDocument/2006/relationships" xmlns:a="http://schemas.openxmlformats.org/drawingml/2006/main" r:embed="R285dfee9f7844246"/>
+          <a:blip xmlns:r="http://schemas.openxmlformats.org/officeDocument/2006/relationships" xmlns:a="http://schemas.openxmlformats.org/drawingml/2006/main" r:embed="R93ab517b72fe499e"/>
           <a:stretch xmlns:a="http://schemas.openxmlformats.org/drawingml/2006/main">
             <a:fillRect l="0" t="0" r="0" b="0"/>
           </a:stretch>
@@ -11448,7 +11428,7 @@
             <a:r>
               <a:rPr sz="1050" b="1">
                 <a:solidFill>
-                  <a:srgbClr val="0F172A"/>
+                  <a:srgbClr val="0E1729"/>
                 </a:solidFill>
                 <a:latin typeface="Arial"/>
                 <a:ea typeface="Arial"/>
@@ -11464,7 +11444,7 @@
             <a:r>
               <a:rPr sz="900">
                 <a:solidFill>
-                  <a:srgbClr val="64748B"/>
+                  <a:srgbClr val="0E1729"/>
                 </a:solidFill>
                 <a:latin typeface="Arial"/>
                 <a:ea typeface="Arial"/>
@@ -11527,7 +11507,7 @@
             <a:avLst/>
           </a:prstGeom>
           <a:solidFill xmlns:a="http://schemas.openxmlformats.org/drawingml/2006/main">
-            <a:srgbClr val="F59E0B"/>
+            <a:srgbClr val="F5B335"/>
           </a:solidFill>
         </p:spPr>
       </p:sp>
@@ -11610,7 +11590,7 @@
             <a:r>
               <a:rPr sz="2700" b="1">
                 <a:solidFill>
-                  <a:srgbClr val="0F172A"/>
+                  <a:srgbClr val="0E1729"/>
                 </a:solidFill>
                 <a:latin typeface="Arial"/>
                 <a:ea typeface="Arial"/>
@@ -11689,7 +11669,7 @@
             <a:avLst/>
           </a:prstGeom>
           <a:solidFill xmlns:a="http://schemas.openxmlformats.org/drawingml/2006/main">
-            <a:srgbClr val="0F172A"/>
+            <a:srgbClr val="0E1729"/>
           </a:solidFill>
         </p:spPr>
       </p:sp>
@@ -11822,7 +11802,7 @@
             <a:avLst/>
           </a:prstGeom>
           <a:solidFill xmlns:a="http://schemas.openxmlformats.org/drawingml/2006/main">
-            <a:srgbClr val="1E293B"/>
+            <a:srgbClr val="16233D"/>
           </a:solidFill>
         </p:spPr>
       </p:sp>
@@ -11955,7 +11935,7 @@
             <a:avLst/>
           </a:prstGeom>
           <a:solidFill xmlns:a="http://schemas.openxmlformats.org/drawingml/2006/main">
-            <a:srgbClr val="334155"/>
+            <a:srgbClr val="22355A"/>
           </a:solidFill>
         </p:spPr>
       </p:sp>
@@ -12088,7 +12068,7 @@
             <a:avLst/>
           </a:prstGeom>
           <a:solidFill xmlns:a="http://schemas.openxmlformats.org/drawingml/2006/main">
-            <a:srgbClr val="F59E0B"/>
+            <a:srgbClr val="F5B335"/>
           </a:solidFill>
         </p:spPr>
       </p:sp>
@@ -12126,7 +12106,7 @@
             <a:r>
               <a:rPr sz="1400" b="1">
                 <a:solidFill>
-                  <a:srgbClr val="0F172A"/>
+                  <a:srgbClr val="0E1729"/>
                 </a:solidFill>
                 <a:latin typeface="Arial"/>
                 <a:ea typeface="Arial"/>
@@ -12223,7 +12203,7 @@
             </a:avLst>
           </a:prstGeom>
           <a:solidFill xmlns:a="http://schemas.openxmlformats.org/drawingml/2006/main">
-            <a:srgbClr val="F1F5F9"/>
+            <a:srgbClr val="F7F5F2"/>
           </a:solidFill>
         </p:spPr>
       </p:sp>
@@ -12261,7 +12241,7 @@
             <a:r>
               <a:rPr sz="1400" b="1">
                 <a:solidFill>
-                  <a:srgbClr val="0F172A"/>
+                  <a:srgbClr val="0E1729"/>
                 </a:solidFill>
                 <a:latin typeface="Arial"/>
                 <a:ea typeface="Arial"/>
@@ -12295,7 +12275,7 @@
             <a:avLst/>
           </a:prstGeom>
           <a:solidFill xmlns:a="http://schemas.openxmlformats.org/drawingml/2006/main">
-            <a:srgbClr val="0F172A"/>
+            <a:srgbClr val="0E1729"/>
           </a:solidFill>
         </p:spPr>
       </p:sp>
@@ -12308,7 +12288,7 @@
           <p:nvPr/>
         </p:nvPicPr>
         <p:blipFill>
-          <a:blip xmlns:r="http://schemas.openxmlformats.org/officeDocument/2006/relationships" xmlns:a="http://schemas.openxmlformats.org/drawingml/2006/main" r:embed="Rf593614d63314ff9"/>
+          <a:blip xmlns:r="http://schemas.openxmlformats.org/officeDocument/2006/relationships" xmlns:a="http://schemas.openxmlformats.org/drawingml/2006/main" r:embed="Rcab63e06fa4441c6"/>
           <a:stretch xmlns:a="http://schemas.openxmlformats.org/drawingml/2006/main">
             <a:fillRect l="0" t="0" r="0" b="0"/>
           </a:stretch>
@@ -12360,7 +12340,7 @@
             <a:r>
               <a:rPr sz="1150" b="1">
                 <a:solidFill>
-                  <a:srgbClr val="1E293B"/>
+                  <a:srgbClr val="16233D"/>
                 </a:solidFill>
                 <a:latin typeface="Arial"/>
                 <a:ea typeface="Arial"/>
@@ -12376,7 +12356,7 @@
             <a:r>
               <a:rPr sz="950">
                 <a:solidFill>
-                  <a:srgbClr val="64748B"/>
+                  <a:srgbClr val="16233D"/>
                 </a:solidFill>
                 <a:latin typeface="Arial"/>
                 <a:ea typeface="Arial"/>
@@ -12392,7 +12372,7 @@
             <a:r>
               <a:rPr sz="950">
                 <a:solidFill>
-                  <a:srgbClr val="64748B"/>
+                  <a:srgbClr val="16233D"/>
                 </a:solidFill>
                 <a:latin typeface="Arial"/>
                 <a:ea typeface="Arial"/>
@@ -12426,7 +12406,7 @@
             <a:avLst/>
           </a:prstGeom>
           <a:solidFill xmlns:a="http://schemas.openxmlformats.org/drawingml/2006/main">
-            <a:srgbClr val="0F172A"/>
+            <a:srgbClr val="0E1729"/>
           </a:solidFill>
         </p:spPr>
       </p:sp>
@@ -12439,7 +12419,7 @@
           <p:nvPr/>
         </p:nvPicPr>
         <p:blipFill>
-          <a:blip xmlns:r="http://schemas.openxmlformats.org/officeDocument/2006/relationships" xmlns:a="http://schemas.openxmlformats.org/drawingml/2006/main" r:embed="R5f13420912da4e06"/>
+          <a:blip xmlns:r="http://schemas.openxmlformats.org/officeDocument/2006/relationships" xmlns:a="http://schemas.openxmlformats.org/drawingml/2006/main" r:embed="R4fac9ee0189445f4"/>
           <a:stretch xmlns:a="http://schemas.openxmlformats.org/drawingml/2006/main">
             <a:fillRect l="0" t="0" r="0" b="0"/>
           </a:stretch>
@@ -12491,7 +12471,7 @@
             <a:r>
               <a:rPr sz="1150" b="1">
                 <a:solidFill>
-                  <a:srgbClr val="1E293B"/>
+                  <a:srgbClr val="16233D"/>
                 </a:solidFill>
                 <a:latin typeface="Arial"/>
                 <a:ea typeface="Arial"/>
@@ -12507,7 +12487,7 @@
             <a:r>
               <a:rPr sz="950">
                 <a:solidFill>
-                  <a:srgbClr val="64748B"/>
+                  <a:srgbClr val="16233D"/>
                 </a:solidFill>
                 <a:latin typeface="Arial"/>
                 <a:ea typeface="Arial"/>
@@ -12523,7 +12503,7 @@
             <a:r>
               <a:rPr sz="950">
                 <a:solidFill>
-                  <a:srgbClr val="64748B"/>
+                  <a:srgbClr val="16233D"/>
                 </a:solidFill>
                 <a:latin typeface="Arial"/>
                 <a:ea typeface="Arial"/>
@@ -12557,7 +12537,7 @@
             <a:avLst/>
           </a:prstGeom>
           <a:solidFill xmlns:a="http://schemas.openxmlformats.org/drawingml/2006/main">
-            <a:srgbClr val="0F172A"/>
+            <a:srgbClr val="0E1729"/>
           </a:solidFill>
         </p:spPr>
       </p:sp>
@@ -12570,7 +12550,7 @@
           <p:nvPr/>
         </p:nvPicPr>
         <p:blipFill>
-          <a:blip xmlns:r="http://schemas.openxmlformats.org/officeDocument/2006/relationships" xmlns:a="http://schemas.openxmlformats.org/drawingml/2006/main" r:embed="R802f70815e014c17"/>
+          <a:blip xmlns:r="http://schemas.openxmlformats.org/officeDocument/2006/relationships" xmlns:a="http://schemas.openxmlformats.org/drawingml/2006/main" r:embed="R72dc3eba61414a84"/>
           <a:stretch xmlns:a="http://schemas.openxmlformats.org/drawingml/2006/main">
             <a:fillRect l="0" t="0" r="0" b="0"/>
           </a:stretch>
@@ -12622,7 +12602,7 @@
             <a:r>
               <a:rPr sz="1150" b="1">
                 <a:solidFill>
-                  <a:srgbClr val="1E293B"/>
+                  <a:srgbClr val="16233D"/>
                 </a:solidFill>
                 <a:latin typeface="Arial"/>
                 <a:ea typeface="Arial"/>
@@ -12638,7 +12618,7 @@
             <a:r>
               <a:rPr sz="950">
                 <a:solidFill>
-                  <a:srgbClr val="64748B"/>
+                  <a:srgbClr val="16233D"/>
                 </a:solidFill>
                 <a:latin typeface="Arial"/>
                 <a:ea typeface="Arial"/>
@@ -12654,7 +12634,7 @@
             <a:r>
               <a:rPr sz="950">
                 <a:solidFill>
-                  <a:srgbClr val="64748B"/>
+                  <a:srgbClr val="16233D"/>
                 </a:solidFill>
                 <a:latin typeface="Arial"/>
                 <a:ea typeface="Arial"/>
@@ -12690,7 +12670,7 @@
             </a:avLst>
           </a:prstGeom>
           <a:solidFill xmlns:a="http://schemas.openxmlformats.org/drawingml/2006/main">
-            <a:srgbClr val="0F172A"/>
+            <a:srgbClr val="0E1729"/>
           </a:solidFill>
         </p:spPr>
       </p:sp>
@@ -12717,7 +12697,7 @@
             <a:avLst/>
           </a:prstGeom>
           <a:solidFill xmlns:a="http://schemas.openxmlformats.org/drawingml/2006/main">
-            <a:srgbClr val="334155"/>
+            <a:srgbClr val="22355A"/>
           </a:solidFill>
         </p:spPr>
       </p:sp>
@@ -12730,7 +12710,7 @@
           <p:nvPr/>
         </p:nvPicPr>
         <p:blipFill>
-          <a:blip xmlns:r="http://schemas.openxmlformats.org/officeDocument/2006/relationships" xmlns:a="http://schemas.openxmlformats.org/drawingml/2006/main" r:embed="R610e54b6a6de4a77"/>
+          <a:blip xmlns:r="http://schemas.openxmlformats.org/officeDocument/2006/relationships" xmlns:a="http://schemas.openxmlformats.org/drawingml/2006/main" r:embed="R04c6899ec0044aff"/>
           <a:stretch xmlns:a="http://schemas.openxmlformats.org/drawingml/2006/main">
             <a:fillRect l="0" t="0" r="0" b="0"/>
           </a:stretch>
@@ -12861,7 +12841,7 @@
             <a:avLst/>
           </a:prstGeom>
           <a:solidFill xmlns:a="http://schemas.openxmlformats.org/drawingml/2006/main">
-            <a:srgbClr val="F59E0B"/>
+            <a:srgbClr val="F5B335"/>
           </a:solidFill>
         </p:spPr>
       </p:sp>
@@ -12944,7 +12924,7 @@
             <a:r>
               <a:rPr sz="2700" b="1">
                 <a:solidFill>
-                  <a:srgbClr val="0F172A"/>
+                  <a:srgbClr val="0E1729"/>
                 </a:solidFill>
                 <a:latin typeface="Arial"/>
                 <a:ea typeface="Arial"/>
@@ -13025,7 +13005,7 @@
             </a:avLst>
           </a:prstGeom>
           <a:solidFill xmlns:a="http://schemas.openxmlformats.org/drawingml/2006/main">
-            <a:srgbClr val="F8FAFC"/>
+            <a:srgbClr val="FBFAF7"/>
           </a:solidFill>
           <a:ln xmlns:a="http://schemas.openxmlformats.org/drawingml/2006/main" w="12700">
             <a:solidFill>
@@ -13058,7 +13038,7 @@
             <a:avLst/>
           </a:prstGeom>
           <a:solidFill xmlns:a="http://schemas.openxmlformats.org/drawingml/2006/main">
-            <a:srgbClr val="0F172A"/>
+            <a:srgbClr val="0E1729"/>
           </a:solidFill>
         </p:spPr>
       </p:sp>
@@ -13071,7 +13051,7 @@
           <p:nvPr/>
         </p:nvPicPr>
         <p:blipFill>
-          <a:blip xmlns:r="http://schemas.openxmlformats.org/officeDocument/2006/relationships" xmlns:a="http://schemas.openxmlformats.org/drawingml/2006/main" r:embed="Rf36cd182fd2c470a"/>
+          <a:blip xmlns:r="http://schemas.openxmlformats.org/officeDocument/2006/relationships" xmlns:a="http://schemas.openxmlformats.org/drawingml/2006/main" r:embed="R349d8ea0787d44eb"/>
           <a:stretch xmlns:a="http://schemas.openxmlformats.org/drawingml/2006/main">
             <a:fillRect l="0" t="0" r="0" b="0"/>
           </a:stretch>
@@ -13120,7 +13100,7 @@
             <a:r>
               <a:rPr sz="1500" b="1">
                 <a:solidFill>
-                  <a:srgbClr val="0F172A"/>
+                  <a:srgbClr val="0E1729"/>
                 </a:solidFill>
                 <a:latin typeface="Arial"/>
                 <a:ea typeface="Arial"/>
@@ -13227,7 +13207,7 @@
             <a:r>
               <a:rPr sz="1100" b="1">
                 <a:solidFill>
-                  <a:srgbClr val="1E293B"/>
+                  <a:srgbClr val="16233D"/>
                 </a:solidFill>
                 <a:latin typeface="Arial"/>
                 <a:ea typeface="Arial"/>
@@ -13379,7 +13359,7 @@
             <a:r>
               <a:rPr sz="1100" b="1">
                 <a:solidFill>
-                  <a:srgbClr val="1E293B"/>
+                  <a:srgbClr val="16233D"/>
                 </a:solidFill>
                 <a:latin typeface="Arial"/>
                 <a:ea typeface="Arial"/>
@@ -13493,7 +13473,7 @@
             <a:avLst/>
           </a:prstGeom>
           <a:solidFill xmlns:a="http://schemas.openxmlformats.org/drawingml/2006/main">
-            <a:srgbClr val="F59E0B"/>
+            <a:srgbClr val="F5B335"/>
           </a:solidFill>
         </p:spPr>
       </p:sp>
@@ -13531,7 +13511,7 @@
             <a:r>
               <a:rPr sz="1100" b="1">
                 <a:solidFill>
-                  <a:srgbClr val="1E293B"/>
+                  <a:srgbClr val="16233D"/>
                 </a:solidFill>
                 <a:latin typeface="Arial"/>
                 <a:ea typeface="Arial"/>
@@ -13698,7 +13678,7 @@
             </a:avLst>
           </a:prstGeom>
           <a:solidFill xmlns:a="http://schemas.openxmlformats.org/drawingml/2006/main">
-            <a:srgbClr val="F8FAFC"/>
+            <a:srgbClr val="FBFAF7"/>
           </a:solidFill>
           <a:ln xmlns:a="http://schemas.openxmlformats.org/drawingml/2006/main" w="12700">
             <a:solidFill>
@@ -13731,7 +13711,7 @@
             <a:avLst/>
           </a:prstGeom>
           <a:solidFill xmlns:a="http://schemas.openxmlformats.org/drawingml/2006/main">
-            <a:srgbClr val="F59E0B"/>
+            <a:srgbClr val="F5B335"/>
           </a:solidFill>
         </p:spPr>
       </p:sp>
@@ -13744,7 +13724,7 @@
           <p:nvPr/>
         </p:nvPicPr>
         <p:blipFill>
-          <a:blip xmlns:r="http://schemas.openxmlformats.org/officeDocument/2006/relationships" xmlns:a="http://schemas.openxmlformats.org/drawingml/2006/main" r:embed="R06f8cfa84492491a"/>
+          <a:blip xmlns:r="http://schemas.openxmlformats.org/officeDocument/2006/relationships" xmlns:a="http://schemas.openxmlformats.org/drawingml/2006/main" r:embed="R0bbe78ecba424ea5"/>
           <a:stretch xmlns:a="http://schemas.openxmlformats.org/drawingml/2006/main">
             <a:fillRect l="0" t="0" r="0" b="0"/>
           </a:stretch>
@@ -13793,7 +13773,7 @@
             <a:r>
               <a:rPr sz="1500" b="1">
                 <a:solidFill>
-                  <a:srgbClr val="0F172A"/>
+                  <a:srgbClr val="0E1729"/>
                 </a:solidFill>
                 <a:latin typeface="Arial"/>
                 <a:ea typeface="Arial"/>
@@ -13883,7 +13863,7 @@
             <a:r>
               <a:rPr sz="1100">
                 <a:solidFill>
-                  <a:srgbClr val="1E293B"/>
+                  <a:srgbClr val="16233D"/>
                 </a:solidFill>
                 <a:latin typeface="Arial"/>
                 <a:ea typeface="Arial"/>
@@ -14049,7 +14029,7 @@
             <a:r>
               <a:rPr sz="1100">
                 <a:solidFill>
-                  <a:srgbClr val="1E293B"/>
+                  <a:srgbClr val="16233D"/>
                 </a:solidFill>
                 <a:latin typeface="Arial"/>
                 <a:ea typeface="Arial"/>
@@ -14215,7 +14195,7 @@
             <a:r>
               <a:rPr sz="1100">
                 <a:solidFill>
-                  <a:srgbClr val="1E293B"/>
+                  <a:srgbClr val="16233D"/>
                 </a:solidFill>
                 <a:latin typeface="Arial"/>
                 <a:ea typeface="Arial"/>
@@ -14381,7 +14361,7 @@
             <a:r>
               <a:rPr sz="1100">
                 <a:solidFill>
-                  <a:srgbClr val="1E293B"/>
+                  <a:srgbClr val="16233D"/>
                 </a:solidFill>
                 <a:latin typeface="Arial"/>
                 <a:ea typeface="Arial"/>
@@ -14563,7 +14543,7 @@
             <a:avLst/>
           </a:prstGeom>
           <a:solidFill xmlns:a="http://schemas.openxmlformats.org/drawingml/2006/main">
-            <a:srgbClr val="F59E0B"/>
+            <a:srgbClr val="F5B335"/>
           </a:solidFill>
         </p:spPr>
       </p:sp>
@@ -14646,7 +14626,7 @@
             <a:r>
               <a:rPr sz="2700" b="1">
                 <a:solidFill>
-                  <a:srgbClr val="0F172A"/>
+                  <a:srgbClr val="0E1729"/>
                 </a:solidFill>
                 <a:latin typeface="Arial"/>
                 <a:ea typeface="Arial"/>
@@ -16601,7 +16581,7 @@
             </a:avLst>
           </a:prstGeom>
           <a:solidFill xmlns:a="http://schemas.openxmlformats.org/drawingml/2006/main">
-            <a:srgbClr val="F1F5F9"/>
+            <a:srgbClr val="F7F5F2"/>
           </a:solidFill>
         </p:spPr>
       </p:sp>
@@ -16628,7 +16608,7 @@
             <a:avLst/>
           </a:prstGeom>
           <a:solidFill xmlns:a="http://schemas.openxmlformats.org/drawingml/2006/main">
-            <a:srgbClr val="F59E0B"/>
+            <a:srgbClr val="F5B335"/>
           </a:solidFill>
         </p:spPr>
       </p:sp>
@@ -16641,7 +16621,7 @@
           <p:nvPr/>
         </p:nvPicPr>
         <p:blipFill>
-          <a:blip xmlns:r="http://schemas.openxmlformats.org/officeDocument/2006/relationships" xmlns:a="http://schemas.openxmlformats.org/drawingml/2006/main" r:embed="Rd930afbe9cfe4ae5"/>
+          <a:blip xmlns:r="http://schemas.openxmlformats.org/officeDocument/2006/relationships" xmlns:a="http://schemas.openxmlformats.org/drawingml/2006/main" r:embed="R7457c09b91ba42e9"/>
           <a:stretch xmlns:a="http://schemas.openxmlformats.org/drawingml/2006/main">
             <a:fillRect l="0" t="0" r="0" b="0"/>
           </a:stretch>
@@ -16693,7 +16673,7 @@
             <a:r>
               <a:rPr sz="1200" b="1">
                 <a:solidFill>
-                  <a:srgbClr val="0F172A"/>
+                  <a:srgbClr val="0E1729"/>
                 </a:solidFill>
                 <a:latin typeface="Arial"/>
                 <a:ea typeface="Arial"/>
@@ -16709,7 +16689,7 @@
             <a:r>
               <a:rPr sz="950">
                 <a:solidFill>
-                  <a:srgbClr val="475569"/>
+                  <a:srgbClr val="0E1729"/>
                 </a:solidFill>
                 <a:latin typeface="Arial"/>
                 <a:ea typeface="Arial"/>
@@ -16725,7 +16705,7 @@
             <a:r>
               <a:rPr sz="950">
                 <a:solidFill>
-                  <a:srgbClr val="475569"/>
+                  <a:srgbClr val="0E1729"/>
                 </a:solidFill>
                 <a:latin typeface="Arial"/>
                 <a:ea typeface="Arial"/>
@@ -16761,7 +16741,7 @@
             </a:avLst>
           </a:prstGeom>
           <a:solidFill xmlns:a="http://schemas.openxmlformats.org/drawingml/2006/main">
-            <a:srgbClr val="F1F5F9"/>
+            <a:srgbClr val="F7F5F2"/>
           </a:solidFill>
         </p:spPr>
       </p:sp>
@@ -16788,7 +16768,7 @@
             <a:avLst/>
           </a:prstGeom>
           <a:solidFill xmlns:a="http://schemas.openxmlformats.org/drawingml/2006/main">
-            <a:srgbClr val="0F172A"/>
+            <a:srgbClr val="0E1729"/>
           </a:solidFill>
         </p:spPr>
       </p:sp>
@@ -16801,7 +16781,7 @@
           <p:nvPr/>
         </p:nvPicPr>
         <p:blipFill>
-          <a:blip xmlns:r="http://schemas.openxmlformats.org/officeDocument/2006/relationships" xmlns:a="http://schemas.openxmlformats.org/drawingml/2006/main" r:embed="R1fad5f614fef4d19"/>
+          <a:blip xmlns:r="http://schemas.openxmlformats.org/officeDocument/2006/relationships" xmlns:a="http://schemas.openxmlformats.org/drawingml/2006/main" r:embed="Rb2ba2a7d161341de"/>
           <a:stretch xmlns:a="http://schemas.openxmlformats.org/drawingml/2006/main">
             <a:fillRect l="0" t="0" r="0" b="0"/>
           </a:stretch>
@@ -16853,7 +16833,7 @@
             <a:r>
               <a:rPr sz="1200" b="1">
                 <a:solidFill>
-                  <a:srgbClr val="0F172A"/>
+                  <a:srgbClr val="0E1729"/>
                 </a:solidFill>
                 <a:latin typeface="Arial"/>
                 <a:ea typeface="Arial"/>
@@ -16869,7 +16849,7 @@
             <a:r>
               <a:rPr sz="950">
                 <a:solidFill>
-                  <a:srgbClr val="475569"/>
+                  <a:srgbClr val="0E1729"/>
                 </a:solidFill>
                 <a:latin typeface="Arial"/>
                 <a:ea typeface="Arial"/>
@@ -16885,7 +16865,7 @@
             <a:r>
               <a:rPr sz="950">
                 <a:solidFill>
-                  <a:srgbClr val="475569"/>
+                  <a:srgbClr val="0E1729"/>
                 </a:solidFill>
                 <a:latin typeface="Arial"/>
                 <a:ea typeface="Arial"/>
@@ -16921,7 +16901,7 @@
             </a:avLst>
           </a:prstGeom>
           <a:solidFill xmlns:a="http://schemas.openxmlformats.org/drawingml/2006/main">
-            <a:srgbClr val="F1F5F9"/>
+            <a:srgbClr val="F7F5F2"/>
           </a:solidFill>
         </p:spPr>
       </p:sp>
@@ -16948,7 +16928,7 @@
             <a:avLst/>
           </a:prstGeom>
           <a:solidFill xmlns:a="http://schemas.openxmlformats.org/drawingml/2006/main">
-            <a:srgbClr val="0F172A"/>
+            <a:srgbClr val="0E1729"/>
           </a:solidFill>
         </p:spPr>
       </p:sp>
@@ -16961,7 +16941,7 @@
           <p:nvPr/>
         </p:nvPicPr>
         <p:blipFill>
-          <a:blip xmlns:r="http://schemas.openxmlformats.org/officeDocument/2006/relationships" xmlns:a="http://schemas.openxmlformats.org/drawingml/2006/main" r:embed="R1470121d2b214133"/>
+          <a:blip xmlns:r="http://schemas.openxmlformats.org/officeDocument/2006/relationships" xmlns:a="http://schemas.openxmlformats.org/drawingml/2006/main" r:embed="Rc78debb6079d4021"/>
           <a:stretch xmlns:a="http://schemas.openxmlformats.org/drawingml/2006/main">
             <a:fillRect l="0" t="0" r="0" b="0"/>
           </a:stretch>
@@ -17013,7 +16993,7 @@
             <a:r>
               <a:rPr sz="1200" b="1">
                 <a:solidFill>
-                  <a:srgbClr val="0F172A"/>
+                  <a:srgbClr val="0E1729"/>
                 </a:solidFill>
                 <a:latin typeface="Arial"/>
                 <a:ea typeface="Arial"/>
@@ -17029,7 +17009,7 @@
             <a:r>
               <a:rPr sz="950">
                 <a:solidFill>
-                  <a:srgbClr val="475569"/>
+                  <a:srgbClr val="0E1729"/>
                 </a:solidFill>
                 <a:latin typeface="Arial"/>
                 <a:ea typeface="Arial"/>
@@ -17045,7 +17025,7 @@
             <a:r>
               <a:rPr sz="950">
                 <a:solidFill>
-                  <a:srgbClr val="475569"/>
+                  <a:srgbClr val="0E1729"/>
                 </a:solidFill>
                 <a:latin typeface="Arial"/>
                 <a:ea typeface="Arial"/>
@@ -17108,7 +17088,7 @@
             <a:avLst/>
           </a:prstGeom>
           <a:solidFill xmlns:a="http://schemas.openxmlformats.org/drawingml/2006/main">
-            <a:srgbClr val="F59E0B"/>
+            <a:srgbClr val="F5B335"/>
           </a:solidFill>
         </p:spPr>
       </p:sp>
@@ -17191,7 +17171,7 @@
             <a:r>
               <a:rPr sz="2700" b="1">
                 <a:solidFill>
-                  <a:srgbClr val="0F172A"/>
+                  <a:srgbClr val="0E1729"/>
                 </a:solidFill>
                 <a:latin typeface="Arial"/>
                 <a:ea typeface="Arial"/>
@@ -17285,7 +17265,7 @@
             <a:r>
               <a:rPr sz="1350" b="1">
                 <a:solidFill>
-                  <a:srgbClr val="0F172A"/>
+                  <a:srgbClr val="0E1729"/>
                 </a:solidFill>
                 <a:latin typeface="Arial"/>
                 <a:ea typeface="Arial"/>
@@ -17304,7 +17284,7 @@
             <a:r>
               <a:rPr sz="1150">
                 <a:solidFill>
-                  <a:srgbClr val="64748B"/>
+                  <a:srgbClr val="0E1729"/>
                 </a:solidFill>
                 <a:latin typeface="Arial"/>
                 <a:ea typeface="Arial"/>
@@ -17324,7 +17304,7 @@
             <a:r>
               <a:rPr sz="1350" b="1">
                 <a:solidFill>
-                  <a:srgbClr val="0F172A"/>
+                  <a:srgbClr val="0E1729"/>
                 </a:solidFill>
                 <a:latin typeface="Arial"/>
                 <a:ea typeface="Arial"/>
@@ -17343,7 +17323,7 @@
             <a:r>
               <a:rPr sz="1150">
                 <a:solidFill>
-                  <a:srgbClr val="64748B"/>
+                  <a:srgbClr val="0E1729"/>
                 </a:solidFill>
                 <a:latin typeface="Arial"/>
                 <a:ea typeface="Arial"/>
@@ -17363,7 +17343,7 @@
             <a:r>
               <a:rPr sz="1350" b="1">
                 <a:solidFill>
-                  <a:srgbClr val="0F172A"/>
+                  <a:srgbClr val="0E1729"/>
                 </a:solidFill>
                 <a:latin typeface="Arial"/>
                 <a:ea typeface="Arial"/>
@@ -17382,7 +17362,7 @@
             <a:r>
               <a:rPr sz="1150">
                 <a:solidFill>
-                  <a:srgbClr val="64748B"/>
+                  <a:srgbClr val="0E1729"/>
                 </a:solidFill>
                 <a:latin typeface="Arial"/>
                 <a:ea typeface="Arial"/>
@@ -17402,7 +17382,7 @@
             <a:r>
               <a:rPr sz="1350" b="1">
                 <a:solidFill>
-                  <a:srgbClr val="0F172A"/>
+                  <a:srgbClr val="0E1729"/>
                 </a:solidFill>
                 <a:latin typeface="Arial"/>
                 <a:ea typeface="Arial"/>
@@ -17421,7 +17401,7 @@
             <a:r>
               <a:rPr sz="1150">
                 <a:solidFill>
-                  <a:srgbClr val="64748B"/>
+                  <a:srgbClr val="0E1729"/>
                 </a:solidFill>
                 <a:latin typeface="Arial"/>
                 <a:ea typeface="Arial"/>
@@ -17441,7 +17421,7 @@
             <a:r>
               <a:rPr sz="1350" b="1">
                 <a:solidFill>
-                  <a:srgbClr val="0F172A"/>
+                  <a:srgbClr val="0E1729"/>
                 </a:solidFill>
                 <a:latin typeface="Arial"/>
                 <a:ea typeface="Arial"/>
@@ -17460,7 +17440,7 @@
             <a:r>
               <a:rPr sz="1150">
                 <a:solidFill>
-                  <a:srgbClr val="64748B"/>
+                  <a:srgbClr val="0E1729"/>
                 </a:solidFill>
                 <a:latin typeface="Arial"/>
                 <a:ea typeface="Arial"/>
@@ -17567,7 +17547,7 @@
             <a:r>
               <a:rPr sz="1250" b="1">
                 <a:solidFill>
-                  <a:srgbClr val="1E293B"/>
+                  <a:srgbClr val="16233D"/>
                 </a:solidFill>
                 <a:latin typeface="Arial"/>
                 <a:ea typeface="Arial"/>
@@ -17719,7 +17699,7 @@
             <a:r>
               <a:rPr sz="1250" b="1">
                 <a:solidFill>
-                  <a:srgbClr val="1E293B"/>
+                  <a:srgbClr val="16233D"/>
                 </a:solidFill>
                 <a:latin typeface="Arial"/>
                 <a:ea typeface="Arial"/>
@@ -17871,7 +17851,7 @@
             <a:r>
               <a:rPr sz="1250" b="1">
                 <a:solidFill>
-                  <a:srgbClr val="1E293B"/>
+                  <a:srgbClr val="16233D"/>
                 </a:solidFill>
                 <a:latin typeface="Arial"/>
                 <a:ea typeface="Arial"/>
@@ -18023,7 +18003,7 @@
             <a:r>
               <a:rPr sz="1250" b="1">
                 <a:solidFill>
-                  <a:srgbClr val="1E293B"/>
+                  <a:srgbClr val="16233D"/>
                 </a:solidFill>
                 <a:latin typeface="Arial"/>
                 <a:ea typeface="Arial"/>
@@ -18175,7 +18155,7 @@
             <a:r>
               <a:rPr sz="1250" b="1">
                 <a:solidFill>
-                  <a:srgbClr val="1E293B"/>
+                  <a:srgbClr val="16233D"/>
                 </a:solidFill>
                 <a:latin typeface="Arial"/>
                 <a:ea typeface="Arial"/>
@@ -18327,7 +18307,7 @@
             <a:r>
               <a:rPr sz="1250" b="1">
                 <a:solidFill>
-                  <a:srgbClr val="1E293B"/>
+                  <a:srgbClr val="16233D"/>
                 </a:solidFill>
                 <a:latin typeface="Arial"/>
                 <a:ea typeface="Arial"/>
@@ -18479,7 +18459,7 @@
             <a:r>
               <a:rPr sz="1250" b="1">
                 <a:solidFill>
-                  <a:srgbClr val="1E293B"/>
+                  <a:srgbClr val="16233D"/>
                 </a:solidFill>
                 <a:latin typeface="Arial"/>
                 <a:ea typeface="Arial"/>
@@ -18631,7 +18611,7 @@
             <a:r>
               <a:rPr sz="1250" b="1">
                 <a:solidFill>
-                  <a:srgbClr val="F8FAFC"/>
+                  <a:srgbClr val="FFFFFF"/>
                 </a:solidFill>
                 <a:latin typeface="Arial"/>
                 <a:ea typeface="Arial"/>
@@ -18784,7 +18764,7 @@
             <a:avLst/>
           </a:prstGeom>
           <a:solidFill xmlns:a="http://schemas.openxmlformats.org/drawingml/2006/main">
-            <a:srgbClr val="F59E0B"/>
+            <a:srgbClr val="F5B335"/>
           </a:solidFill>
         </p:spPr>
       </p:sp>
@@ -18867,7 +18847,7 @@
             <a:r>
               <a:rPr sz="2700" b="1">
                 <a:solidFill>
-                  <a:srgbClr val="0F172A"/>
+                  <a:srgbClr val="0E1729"/>
                 </a:solidFill>
                 <a:latin typeface="Arial"/>
                 <a:ea typeface="Arial"/>
@@ -18961,7 +18941,7 @@
             <a:r>
               <a:rPr sz="1350" b="1">
                 <a:solidFill>
-                  <a:srgbClr val="0F172A"/>
+                  <a:srgbClr val="0E1729"/>
                 </a:solidFill>
                 <a:latin typeface="Arial"/>
                 <a:ea typeface="Arial"/>
@@ -18980,7 +18960,7 @@
             <a:r>
               <a:rPr sz="1150">
                 <a:solidFill>
-                  <a:srgbClr val="64748B"/>
+                  <a:srgbClr val="0E1729"/>
                 </a:solidFill>
                 <a:latin typeface="Arial"/>
                 <a:ea typeface="Arial"/>
@@ -19000,7 +18980,7 @@
             <a:r>
               <a:rPr sz="1350" b="1">
                 <a:solidFill>
-                  <a:srgbClr val="0F172A"/>
+                  <a:srgbClr val="0E1729"/>
                 </a:solidFill>
                 <a:latin typeface="Arial"/>
                 <a:ea typeface="Arial"/>
@@ -19019,7 +18999,7 @@
             <a:r>
               <a:rPr sz="1150">
                 <a:solidFill>
-                  <a:srgbClr val="64748B"/>
+                  <a:srgbClr val="0E1729"/>
                 </a:solidFill>
                 <a:latin typeface="Arial"/>
                 <a:ea typeface="Arial"/>
@@ -19039,7 +19019,7 @@
             <a:r>
               <a:rPr sz="1350" b="1">
                 <a:solidFill>
-                  <a:srgbClr val="0F172A"/>
+                  <a:srgbClr val="0E1729"/>
                 </a:solidFill>
                 <a:latin typeface="Arial"/>
                 <a:ea typeface="Arial"/>
@@ -19058,7 +19038,7 @@
             <a:r>
               <a:rPr sz="1150">
                 <a:solidFill>
-                  <a:srgbClr val="64748B"/>
+                  <a:srgbClr val="0E1729"/>
                 </a:solidFill>
                 <a:latin typeface="Arial"/>
                 <a:ea typeface="Arial"/>
@@ -19078,7 +19058,7 @@
             <a:r>
               <a:rPr sz="1350" b="1">
                 <a:solidFill>
-                  <a:srgbClr val="0F172A"/>
+                  <a:srgbClr val="0E1729"/>
                 </a:solidFill>
                 <a:latin typeface="Arial"/>
                 <a:ea typeface="Arial"/>
@@ -19097,7 +19077,7 @@
             <a:r>
               <a:rPr sz="1150">
                 <a:solidFill>
-                  <a:srgbClr val="64748B"/>
+                  <a:srgbClr val="0E1729"/>
                 </a:solidFill>
                 <a:latin typeface="Arial"/>
                 <a:ea typeface="Arial"/>
@@ -19117,7 +19097,7 @@
             <a:r>
               <a:rPr sz="1350" b="1">
                 <a:solidFill>
-                  <a:srgbClr val="0F172A"/>
+                  <a:srgbClr val="0E1729"/>
                 </a:solidFill>
                 <a:latin typeface="Arial"/>
                 <a:ea typeface="Arial"/>
@@ -19136,7 +19116,7 @@
             <a:r>
               <a:rPr sz="1150">
                 <a:solidFill>
-                  <a:srgbClr val="64748B"/>
+                  <a:srgbClr val="0E1729"/>
                 </a:solidFill>
                 <a:latin typeface="Arial"/>
                 <a:ea typeface="Arial"/>
@@ -19176,7 +19156,7 @@
           </a:solidFill>
           <a:ln xmlns:a="http://schemas.openxmlformats.org/drawingml/2006/main" w="31750">
             <a:solidFill>
-              <a:srgbClr val="0F172A"/>
+              <a:srgbClr val="0E1729"/>
             </a:solidFill>
             <a:prstDash val="solid"/>
           </a:ln>
@@ -19252,7 +19232,7 @@
             <a:r>
               <a:rPr sz="1050" b="1">
                 <a:solidFill>
-                  <a:srgbClr val="0F172A"/>
+                  <a:srgbClr val="0E1729"/>
                 </a:solidFill>
                 <a:latin typeface="Arial"/>
                 <a:ea typeface="Arial"/>
@@ -19288,7 +19268,7 @@
             </a:avLst>
           </a:prstGeom>
           <a:solidFill xmlns:a="http://schemas.openxmlformats.org/drawingml/2006/main">
-            <a:srgbClr val="0F172A"/>
+            <a:srgbClr val="0E1729"/>
           </a:solidFill>
         </p:spPr>
       </p:sp>
@@ -19326,7 +19306,7 @@
             <a:r>
               <a:rPr sz="3400" b="1">
                 <a:solidFill>
-                  <a:srgbClr val="FBBF24"/>
+                  <a:srgbClr val="F5B335"/>
                 </a:solidFill>
                 <a:latin typeface="Arial"/>
                 <a:ea typeface="Arial"/>
@@ -19471,7 +19451,7 @@
             </a:avLst>
           </a:prstGeom>
           <a:solidFill xmlns:a="http://schemas.openxmlformats.org/drawingml/2006/main">
-            <a:srgbClr val="F1F5F9"/>
+            <a:srgbClr val="F7F5F2"/>
           </a:solidFill>
         </p:spPr>
       </p:sp>
@@ -19554,7 +19534,7 @@
             <a:r>
               <a:rPr sz="950" b="1">
                 <a:solidFill>
-                  <a:srgbClr val="1E293B"/>
+                  <a:srgbClr val="16233D"/>
                 </a:solidFill>
                 <a:latin typeface="Arial"/>
                 <a:ea typeface="Arial"/>
@@ -19590,7 +19570,7 @@
             </a:avLst>
           </a:prstGeom>
           <a:solidFill xmlns:a="http://schemas.openxmlformats.org/drawingml/2006/main">
-            <a:srgbClr val="F1F5F9"/>
+            <a:srgbClr val="F7F5F2"/>
           </a:solidFill>
         </p:spPr>
       </p:sp>
@@ -19673,7 +19653,7 @@
             <a:r>
               <a:rPr sz="950" b="1">
                 <a:solidFill>
-                  <a:srgbClr val="1E293B"/>
+                  <a:srgbClr val="16233D"/>
                 </a:solidFill>
                 <a:latin typeface="Arial"/>
                 <a:ea typeface="Arial"/>
@@ -19940,15 +19920,15 @@
 <file path=ppt/theme/theme1.xml><?xml version="1.0" encoding="utf-8"?>
 <a:theme xmlns:a="http://schemas.openxmlformats.org/drawingml/2006/main" name="Office Theme">
   <a:themeElements>
-    <a:clrScheme name="Office">
+    <a:clrScheme name="PWE Studio Family">
       <a:dk1>
-        <a:sysClr val="windowText" lastClr="000000"/>
+        <a:srgbClr val="000000"/>
       </a:dk1>
       <a:lt1>
-        <a:sysClr val="window" lastClr="FFFFFF"/>
+        <a:srgbClr val="FFFFFF"/>
       </a:lt1>
       <a:dk2>
-        <a:srgbClr val="44546A"/>
+        <a:srgbClr val="16233D"/>
       </a:dk2>
       <a:lt2>
         <a:srgbClr val="E7E6E6"/>
@@ -19963,7 +19943,7 @@
         <a:srgbClr val="A5A5A5"/>
       </a:accent3>
       <a:accent4>
-        <a:srgbClr val="FFC000"/>
+        <a:srgbClr val="F5B335"/>
       </a:accent4>
       <a:accent5>
         <a:srgbClr val="5B9BD5"/>
@@ -19972,7 +19952,7 @@
         <a:srgbClr val="70AD47"/>
       </a:accent6>
       <a:hlink>
-        <a:srgbClr val="0563C1"/>
+        <a:srgbClr val="2563EB"/>
       </a:hlink>
       <a:folHlink>
         <a:srgbClr val="954F72"/>
@@ -20084,7 +20064,7 @@
         <a:font script="Tfng" typeface="Ebrima"/>
       </a:minorFont>
     </a:fontScheme>
-    <a:fmtScheme name="Office">
+    <a:fmtScheme name="PWE Studio Family">
       <a:fillStyleLst>
         <a:solidFill>
           <a:schemeClr val="phClr"/>

</xml_diff>